<commit_message>
Visual evidence pass: real plant records, verified clients, no repeated images
Integrates five photographed plant records (process-parameter record, FG
production records, bristling traceability report) into the flow,
registers and architecture slides, with annotations showing manual
consolidation and the same fact written twice. Adds a verified
contract-manufacturing client row to the JHS slide, removes every repeated
photograph, and adds image sources to speaker notes. Slide 12 and the
client row accept moulding/tufting photos and logos when supplied.
Slide count unchanged at 38.

Co-Authored-By: Claude Opus 5.5 <noreply@anthropic.com>
Claude-Session: https://claude.ai/code/session_01JVPf4Y68vS1p1pzLtGPCLX
</commit_message>
<xml_diff>
--- a/sip-presentation/SIP_Story_Deck.pptx
+++ b/sip-presentation/SIP_Story_Deck.pptx
@@ -789,12 +789,14 @@
 WHY IT MATTERS
 The panel sees a real JHS machine before they see a single bullet point. It signals that this is a story from the shop floor, not a report written from outside.
 WHAT THE PANEL SHOULD NOTICE
-This is an actual photograph from the plant, a tube filling line, not a stock image.
+This is an actual photograph from the plant, the yard between production blocks, not a stock image.
 LIKELY PANEL QUESTIONS &amp; MY ANSWERS
 Q1. Is this a real complaint?
 A: No. It's a traceability scenario I used to design and test the system. I'll use it all the way through because it shows exactly what the MES has to do.
 TRANSITION TO NEXT SLIDE
-So what does the complaint say?</a:t>
+So what does the complaint say?
+IMAGE SOURCES
+Photograph of the plant yard between production blocks, JHS Kala-Amb (image provided by the presenter).</a:t>
             </a:r>
             <a:endParaRPr lang="en-US" dirty="0"/>
           </a:p>
@@ -1187,7 +1189,7 @@
             <a:r>
               <a:rPr lang="en-US" dirty="0"/>
               <a:t>WHAT I SAY
-This is the flow I mapped. Planning decides what to make. The warehouse receives and issues material. Production converts it, QC checks it, packing packs it, and dispatch sends it out. At every step, someone creates a record. So the plant isn't short of records. But these records were created by different people, in different formats, at different times. They didn't automatically join up into one story you could follow from a complaint back to a machine and a material lot.
+This is the flow I mapped. Planning decides what to make. The warehouse receives and issues material. Production converts it, QC checks it, packing packs it, and dispatch sends it out. At every step, someone creates a record. At the bottom are two of them as they actually look: the process-parameter record filled at the bristling machines, and the finished-goods production record filled after packing. So the plant isn't short of records. But these records were created by different people, in different formats, at different times. They didn't automatically join up into one story you could follow from a complaint back to a machine and a material lot.
 WHY IT MATTERS
 This is where I realised the problem wasn't a lack of data.
 WHAT THE PANEL SHOULD NOTICE
@@ -1195,8 +1197,12 @@
 LIKELY PANEL QUESTIONS &amp; MY ANSWERS
 Q1. How did you map this flow?
 A: By walking the process, talking to the people in each function, and looking at the registers and formats they actually filled in.
+Q2. What are the two forms at the bottom?
+A: Real plant formats. On the left, the bristling process-parameter record: speed and pressure for each tufting and trimming machine and the sealing temperatures, checked every shift. On the right, the FG production record: product, brushes per case, batch number and cases packed. They're filled by different people, at different points, on different sheets.
 TRANSITION TO NEXT SLIDE
-And that's what led me to the real finding.</a:t>
+And that's what led me to the real finding.
+IMAGE SOURCES
+Plant record formats photographed during the internship (provided by the presenter): Bristling Process Parameter Monitoring Record (format JHS/QF/8.5.1-1, 11 Jun 2026, shift A); Production Record - FG (format JHS/QF/8.5.1-1/3, 13 Jun 2026, shift A).</a:t>
             </a:r>
             <a:endParaRPr lang="en-US" dirty="0"/>
           </a:p>
@@ -1383,18 +1389,22 @@
             <a:r>
               <a:rPr lang="en-US" dirty="0"/>
               <a:t>WHAT I SAY
-These are the five kinds of record I kept coming back to: production, quality, material, downtime and dispatch. Each one made sense on its own. But to answer a question that crosses them, like our complaint, someone has to search each register manually, then consolidate what they find, usually by hand. That delays the investigation, and it means management only sees the full picture when someone has done that work. So the issue was structural. There was no common key and no automatic link between the registers.
+These are real records from the bristling line. The first is the plant's own traceability report for Patanjali Triple Action, batch JBCA260003. Look at its headers: this column is 'data received from handle tag', this one 'from cap tag', these 'from shift production formats'. Someone builds this report by hand, from other records. And the same fact gets written twice. On 11 June, 25 cases of JBCA260003: once on the FG production record, and again in row 19 of the traceability report. The same page also shows one batch number running across several production days and colours, which is exactly why the batch number alone couldn't identify a run. Behind these are the five kinds of record I kept coming back to: production, quality, material, downtime and dispatch. Each one made sense on its own. But to answer a question that crosses them, like our complaint, someone has to search each register manually, then consolidate what they find, usually by hand. That delays the investigation, and it means management only sees the full picture when someone has done that work. So the issue was structural. There was no common key and no automatic link between the registers.
 WHY IT MATTERS
 This defines what the MES must fix: a shared key and connected flows, not just a nicer report.
 WHAT THE PANEL SHOULD NOTICE
-The registers are deliberately drawn scattered, with nothing joining them. That's the problem in one picture.
+Marker 2 appears on both records: the same fact, written by hand in two places. Nothing links them except a person copying it.
 LIKELY PANEL QUESTIONS &amp; MY ANSWERS
 Q1. Were these registers on paper or in Excel?
-A: Both. Each function kept its own departmental register or spreadsheet. The records were generally accurate. The issue was that they weren't connected to each other.
-Q2. Did you measure how long an investigation took?
+A: Both. Each function kept its own departmental register or spreadsheet. The records were generally accurate. The issue was that they weren't connected to each other. The two on this slide are paper formats, filled by hand and signed.
+Q2. Why does one batch number cover several days?
+A: On this line the batch JBCA260003 ran from 14 May to 13 June, across several production days, colours and handle lots. So a pack's batch number alone can't tell you which day, colour or handle lot you're looking at. That's the real-world version of what I showed with the demonstration data on slide 5.
+Q3. Did you measure how long an investigation took?
 A: No, I didn't formally time it, so I won't put a number on it. What I observed was the number of steps and hand-offs involved.
 TRANSITION TO NEXT SLIDE
-Alongside this, I did a line study, and that gave me a second, more measurable view of the same problem.</a:t>
+Alongside this, I did a line study, and that gave me a second, more measurable view of the same problem.
+IMAGE SOURCES
+Plant records photographed during the internship (provided by the presenter): Traceability Report - Bristling, Patanjali Triple Action, batch JBCA260003 (format JHS/QF/8.5.1-1/9), rows 13-21; Production Record - FG, 11 Jun 2026, shift A (format JHS/QF/8.5.1-1/3).</a:t>
             </a:r>
             <a:endParaRPr lang="en-US" dirty="0"/>
           </a:p>
@@ -1496,7 +1506,9 @@
 Q3. Is one cycle enough?
 A: Not for a performance conclusion, and I don't draw one. It was enough to show me the problem: working out the gap was simple, but explaining it wasn't.
 TRANSITION TO NEXT SLIDE
-So what did the line actually produce?</a:t>
+So what did the line actually produce?
+IMAGE SOURCES
+Tube filling line, paste plant, JHS Kala-Amb (photograph provided by the presenter).</a:t>
             </a:r>
             <a:endParaRPr lang="en-US" dirty="0"/>
           </a:p>
@@ -1985,7 +1997,7 @@
             <a:r>
               <a:rPr lang="en-US" dirty="0"/>
               <a:t>WHAT I SAY
-I organised the workbook into five layers. Master data holds the reference lists: products, colours, machines, materials and ideal speeds. Transaction registers are where daily events are entered: production, quality, material issue, downtime and dispatch. The calculation layer joins and summarises those registers using formulas like SUMIFS, COUNTIFS and INDEX-MATCH. The presentation layer is what users see: dashboards, the trace report and the OEE view. Documentation explains how to use and maintain it. Data flows in one direction, from masters to registers to calculations to outputs.
+I organised the workbook into five layers. Master data holds the reference lists: products, colours, machines, materials and ideal speeds. Transaction registers are where daily events are entered: production, quality, material issue, downtime and dispatch. The calculation layer joins and summarises those registers using formulas like SUMIFS, COUNTIFS and INDEX-MATCH. The presentation layer is what users see: dashboards, the trace report and the OEE view. Documentation explains how to use and maintain it. Data flows in one direction, from masters to registers to calculations to outputs. Bottom right is the plant's own paper traceability report. I used its columns, like handle lot, nylon and brass-wire lots, packing materials and machines, as the fields in my registers, so the system records what the plant already tracks.
 WHY IT MATTERS
 Separating reference data, event data and calculations is basic data modelling. It keeps the system consistent and easier to maintain than one big sheet.
 WHAT THE PANEL SHOULD NOTICE
@@ -1996,7 +2008,9 @@
 Q2. Why not one big sheet?
 A: One sheet mixes reference data, events and calculations. It gets slow, hard to validate and easy to break. Layers keep each job separate.
 TRANSITION TO NEXT SLIDE
-But the layers only work if the records can be linked. And that needs a key.</a:t>
+But the layers only work if the records can be linked. And that needs a key.
+IMAGE SOURCES
+Plant record photographed during the internship (provided by the presenter): Traceability Report - Bristling, Patanjali Triple Action, batch JBCA260003 (format JHS/QF/8.5.1-1/9), rows 1-7.</a:t>
             </a:r>
             <a:endParaRPr lang="en-US" dirty="0"/>
           </a:p>
@@ -4294,7 +4308,9 @@
 Q1. What exactly was your role?
 A: I was an operations intern. I studied the process, observed a production line, gathered requirements from the people using the records, and designed and built the MES prototype.
 TRANSITION TO NEXT SLIDE
-Let me tell you briefly who JHS is.</a:t>
+Let me tell you briefly who JHS is.
+IMAGE SOURCES
+Aerial view of the JHS Kala-Amb facility (image provided by the presenter; add its original credit if it came from JHS).</a:t>
             </a:r>
             <a:endParaRPr lang="en-US" dirty="0"/>
           </a:p>
@@ -4390,11 +4406,16 @@
 The toothbrush line, highlighted, is the one the whole case study follows.
 LIKELY PANEL QUESTIONS &amp; MY ANSWERS
 Q1. Which brands does JHS make for?
-A: Publicly, the company names clients such as Amway India and Dabur India in the domestic market. In my workbook, Amway, Chicco and Dabur are modelled as client accounts, but with fictional data.
+A: Publicly reported clients include Dabur India, Patanjali Ayurved and Amway India; those are the three on the slide. The dashboard later in my deck uses Amway, Chicco and Dabur only as modelled accounts with fictional data, so I don't treat the demonstration data as evidence of who the clients are.
 Q2. Why does contract manufacturing make traceability more important?
 A: Because the brand owner answers to the consumer. If a pack is complained about, the client will expect the manufacturer to identify the run, the materials and the QC record quickly, and to scope any recall precisely.
 TRANSITION TO NEXT SLIDE
-Here's what that looks like on the ground.</a:t>
+Here's what that looks like on the ground.
+IMAGE SOURCES
+Dabur India, Patanjali Ayurved, Amway India: named as contract-manufacturing clients in JHS Svendgaard's company profile (svendgaard.com/about.html) and investor material (svendgaard.com, Investor Presentation).
+Dabur partnership since 2000 and Amway collaboration: Manufacturing Today India, 'No shortcut, only perseverance: JHS Svendgaard's growth story' (manufacturingtodayindia.com/jhs-svendgaards-growth-story).
+Also listed as portfolio context by Sixth Sense Ventures (sixthsenseventures.com/portfolio/jhs-svendgaard-laboratories/).
+Patanjali products also appear on the plant's own FG production and traceability records photographed during the internship.</a:t>
             </a:r>
             <a:endParaRPr lang="en-US" dirty="0"/>
           </a:p>
@@ -4483,7 +4504,7 @@
             <a:r>
               <a:rPr lang="en-US" dirty="0"/>
               <a:t>WHAT I SAY
-These are photographs from the plant. On the left is the yard between production blocks, where material moves between stores, production and dispatch all day. Top right is a tube filling line in the paste plant: empty tubes come in from the hopper, then get filled, coded and sealed. Bottom right is the Kala-Amb industrial belt from the roof. Every one of these operations creates records: what was run, what material was used, what was rejected, when the machine stopped.
+This is the view from the plant roof: production blocks, stores and utilities, with the Kala-Amb industrial belt and the hills behind. Stores, production, QC, packing and dispatch are spread across the campus, and material moves between them all day. Every one of those operations creates records: what was run, what material was used, what was rejected, when the machine stopped.
 WHY IT MATTERS
 It shows the panel I was physically on the floor, and that the system is built around real operations.
 WHAT THE PANEL SHOULD NOTICE
@@ -4492,7 +4513,9 @@
 Q1. Was the MES deployed on these lines?
 A: No. It's a working prototype built on the plant's process and record structure, and populated with a demonstration dataset, not the company's production records. Live deployment would be the next step.
 TRANSITION TO NEXT SLIDE
-So how did I spend my seven weeks there?</a:t>
+So how did I spend my seven weeks there?
+IMAGE SOURCES
+Photograph from the plant roof, JHS Kala-Amb (image provided by the presenter).</a:t>
             </a:r>
             <a:endParaRPr lang="en-US" dirty="0"/>
           </a:p>
@@ -4867,7 +4890,7 @@
       </p:grpSpPr>
       <p:pic>
         <p:nvPicPr>
-          <p:cNvPr id="2" name="Image 0" descr="/home/user/master-executive-system/sip-presentation/source/photos/4.jpg">    </p:cNvPr>
+          <p:cNvPr id="2" name="Image 0" descr="/home/user/master-executive-system/sip-presentation/source/photos/3.jpg">    </p:cNvPr>
           <p:cNvPicPr>
             <a:picLocks noChangeAspect="1"/>
           </p:cNvPicPr>
@@ -8651,8 +8674,8 @@
         </p:nvSpPr>
         <p:spPr>
           <a:xfrm>
-            <a:off x="594360" y="3337560"/>
-            <a:ext cx="1691640" cy="1417320"/>
+            <a:off x="594360" y="3246120"/>
+            <a:ext cx="1691640" cy="1188720"/>
           </a:xfrm>
           <a:prstGeom prst="rect">
             <a:avLst/>
@@ -8671,7 +8694,7 @@
         </p:nvSpPr>
         <p:spPr>
           <a:xfrm>
-            <a:off x="704088" y="3429000"/>
+            <a:off x="704088" y="3319272"/>
             <a:ext cx="1463040" cy="201168"/>
           </a:xfrm>
           <a:prstGeom prst="rect">
@@ -8710,8 +8733,8 @@
         </p:nvSpPr>
         <p:spPr>
           <a:xfrm>
-            <a:off x="704088" y="3657600"/>
-            <a:ext cx="1481328" cy="1005840"/>
+            <a:off x="704088" y="3547872"/>
+            <a:ext cx="1481328" cy="868680"/>
           </a:xfrm>
           <a:prstGeom prst="rect">
             <a:avLst/>
@@ -8727,7 +8750,7 @@
               <a:buNone/>
             </a:pPr>
             <a:r>
-              <a:rPr lang="en-US" sz="1250" b="1" dirty="0">
+              <a:rPr lang="en-US" sz="1200" b="1" dirty="0">
                 <a:solidFill>
                   <a:srgbClr val="1A1D21"/>
                 </a:solidFill>
@@ -8737,7 +8760,7 @@
               </a:rPr>
               <a:t>Production plan</a:t>
             </a:r>
-            <a:endParaRPr lang="en-US" sz="1250" dirty="0"/>
+            <a:endParaRPr lang="en-US" sz="1200" dirty="0"/>
           </a:p>
           <a:p>
             <a:pPr indent="0" marL="0">
@@ -8754,7 +8777,7 @@
               </a:rPr>
               <a:t>What to make, how much, on which line</a:t>
             </a:r>
-            <a:endParaRPr lang="en-US" sz="1250" dirty="0"/>
+            <a:endParaRPr lang="en-US" sz="1200" dirty="0"/>
           </a:p>
         </p:txBody>
       </p:sp>
@@ -8869,8 +8892,8 @@
         </p:nvSpPr>
         <p:spPr>
           <a:xfrm>
-            <a:off x="2487168" y="3337560"/>
-            <a:ext cx="1691640" cy="1417320"/>
+            <a:off x="2487168" y="3246120"/>
+            <a:ext cx="1691640" cy="1188720"/>
           </a:xfrm>
           <a:prstGeom prst="rect">
             <a:avLst/>
@@ -8889,7 +8912,7 @@
         </p:nvSpPr>
         <p:spPr>
           <a:xfrm>
-            <a:off x="2596896" y="3429000"/>
+            <a:off x="2596896" y="3319272"/>
             <a:ext cx="1463040" cy="201168"/>
           </a:xfrm>
           <a:prstGeom prst="rect">
@@ -8928,8 +8951,8 @@
         </p:nvSpPr>
         <p:spPr>
           <a:xfrm>
-            <a:off x="2596896" y="3657600"/>
-            <a:ext cx="1481328" cy="1005840"/>
+            <a:off x="2596896" y="3547872"/>
+            <a:ext cx="1481328" cy="868680"/>
           </a:xfrm>
           <a:prstGeom prst="rect">
             <a:avLst/>
@@ -8945,7 +8968,7 @@
               <a:buNone/>
             </a:pPr>
             <a:r>
-              <a:rPr lang="en-US" sz="1250" b="1" dirty="0">
+              <a:rPr lang="en-US" sz="1200" b="1" dirty="0">
                 <a:solidFill>
                   <a:srgbClr val="1A1D21"/>
                 </a:solidFill>
@@ -8955,7 +8978,7 @@
               </a:rPr>
               <a:t>Material receipt &amp; issue</a:t>
             </a:r>
-            <a:endParaRPr lang="en-US" sz="1250" dirty="0"/>
+            <a:endParaRPr lang="en-US" sz="1200" dirty="0"/>
           </a:p>
           <a:p>
             <a:pPr indent="0" marL="0">
@@ -8972,7 +8995,7 @@
               </a:rPr>
               <a:t>Which lots went to the floor</a:t>
             </a:r>
-            <a:endParaRPr lang="en-US" sz="1250" dirty="0"/>
+            <a:endParaRPr lang="en-US" sz="1200" dirty="0"/>
           </a:p>
         </p:txBody>
       </p:sp>
@@ -9087,8 +9110,8 @@
         </p:nvSpPr>
         <p:spPr>
           <a:xfrm>
-            <a:off x="4379976" y="3337560"/>
-            <a:ext cx="1691640" cy="1417320"/>
+            <a:off x="4379976" y="3246120"/>
+            <a:ext cx="1691640" cy="1188720"/>
           </a:xfrm>
           <a:prstGeom prst="rect">
             <a:avLst/>
@@ -9107,7 +9130,7 @@
         </p:nvSpPr>
         <p:spPr>
           <a:xfrm>
-            <a:off x="4489704" y="3429000"/>
+            <a:off x="4489704" y="3319272"/>
             <a:ext cx="1463040" cy="201168"/>
           </a:xfrm>
           <a:prstGeom prst="rect">
@@ -9146,8 +9169,8 @@
         </p:nvSpPr>
         <p:spPr>
           <a:xfrm>
-            <a:off x="4489704" y="3657600"/>
-            <a:ext cx="1481328" cy="1005840"/>
+            <a:off x="4489704" y="3547872"/>
+            <a:ext cx="1481328" cy="868680"/>
           </a:xfrm>
           <a:prstGeom prst="rect">
             <a:avLst/>
@@ -9163,7 +9186,7 @@
               <a:buNone/>
             </a:pPr>
             <a:r>
-              <a:rPr lang="en-US" sz="1250" b="1" dirty="0">
+              <a:rPr lang="en-US" sz="1200" b="1" dirty="0">
                 <a:solidFill>
                   <a:srgbClr val="1A1D21"/>
                 </a:solidFill>
@@ -9173,7 +9196,7 @@
               </a:rPr>
               <a:t>Production log</a:t>
             </a:r>
-            <a:endParaRPr lang="en-US" sz="1250" dirty="0"/>
+            <a:endParaRPr lang="en-US" sz="1200" dirty="0"/>
           </a:p>
           <a:p>
             <a:pPr indent="0" marL="0">
@@ -9190,7 +9213,7 @@
               </a:rPr>
               <a:t>Output, shift, machine, run time</a:t>
             </a:r>
-            <a:endParaRPr lang="en-US" sz="1250" dirty="0"/>
+            <a:endParaRPr lang="en-US" sz="1200" dirty="0"/>
           </a:p>
         </p:txBody>
       </p:sp>
@@ -9305,8 +9328,8 @@
         </p:nvSpPr>
         <p:spPr>
           <a:xfrm>
-            <a:off x="6272784" y="3337560"/>
-            <a:ext cx="1691640" cy="1417320"/>
+            <a:off x="6272784" y="3246120"/>
+            <a:ext cx="1691640" cy="1188720"/>
           </a:xfrm>
           <a:prstGeom prst="rect">
             <a:avLst/>
@@ -9325,7 +9348,7 @@
         </p:nvSpPr>
         <p:spPr>
           <a:xfrm>
-            <a:off x="6382512" y="3429000"/>
+            <a:off x="6382512" y="3319272"/>
             <a:ext cx="1463040" cy="201168"/>
           </a:xfrm>
           <a:prstGeom prst="rect">
@@ -9364,8 +9387,8 @@
         </p:nvSpPr>
         <p:spPr>
           <a:xfrm>
-            <a:off x="6382512" y="3657600"/>
-            <a:ext cx="1481328" cy="1005840"/>
+            <a:off x="6382512" y="3547872"/>
+            <a:ext cx="1481328" cy="868680"/>
           </a:xfrm>
           <a:prstGeom prst="rect">
             <a:avLst/>
@@ -9381,7 +9404,7 @@
               <a:buNone/>
             </a:pPr>
             <a:r>
-              <a:rPr lang="en-US" sz="1250" b="1" dirty="0">
+              <a:rPr lang="en-US" sz="1200" b="1" dirty="0">
                 <a:solidFill>
                   <a:srgbClr val="1A1D21"/>
                 </a:solidFill>
@@ -9391,7 +9414,7 @@
               </a:rPr>
               <a:t>Inspection record</a:t>
             </a:r>
-            <a:endParaRPr lang="en-US" sz="1250" dirty="0"/>
+            <a:endParaRPr lang="en-US" sz="1200" dirty="0"/>
           </a:p>
           <a:p>
             <a:pPr indent="0" marL="0">
@@ -9408,7 +9431,7 @@
               </a:rPr>
               <a:t>Checks, rejections, release</a:t>
             </a:r>
-            <a:endParaRPr lang="en-US" sz="1250" dirty="0"/>
+            <a:endParaRPr lang="en-US" sz="1200" dirty="0"/>
           </a:p>
         </p:txBody>
       </p:sp>
@@ -9523,8 +9546,8 @@
         </p:nvSpPr>
         <p:spPr>
           <a:xfrm>
-            <a:off x="8165592" y="3337560"/>
-            <a:ext cx="1691640" cy="1417320"/>
+            <a:off x="8165592" y="3246120"/>
+            <a:ext cx="1691640" cy="1188720"/>
           </a:xfrm>
           <a:prstGeom prst="rect">
             <a:avLst/>
@@ -9543,7 +9566,7 @@
         </p:nvSpPr>
         <p:spPr>
           <a:xfrm>
-            <a:off x="8275320" y="3429000"/>
+            <a:off x="8275320" y="3319272"/>
             <a:ext cx="1463040" cy="201168"/>
           </a:xfrm>
           <a:prstGeom prst="rect">
@@ -9582,8 +9605,8 @@
         </p:nvSpPr>
         <p:spPr>
           <a:xfrm>
-            <a:off x="8275320" y="3657600"/>
-            <a:ext cx="1481328" cy="1005840"/>
+            <a:off x="8275320" y="3547872"/>
+            <a:ext cx="1481328" cy="868680"/>
           </a:xfrm>
           <a:prstGeom prst="rect">
             <a:avLst/>
@@ -9599,7 +9622,7 @@
               <a:buNone/>
             </a:pPr>
             <a:r>
-              <a:rPr lang="en-US" sz="1250" b="1" dirty="0">
+              <a:rPr lang="en-US" sz="1200" b="1" dirty="0">
                 <a:solidFill>
                   <a:srgbClr val="1A1D21"/>
                 </a:solidFill>
@@ -9609,7 +9632,7 @@
               </a:rPr>
               <a:t>Packing record</a:t>
             </a:r>
-            <a:endParaRPr lang="en-US" sz="1250" dirty="0"/>
+            <a:endParaRPr lang="en-US" sz="1200" dirty="0"/>
           </a:p>
           <a:p>
             <a:pPr indent="0" marL="0">
@@ -9626,7 +9649,7 @@
               </a:rPr>
               <a:t>Packed quantity, pack coding</a:t>
             </a:r>
-            <a:endParaRPr lang="en-US" sz="1250" dirty="0"/>
+            <a:endParaRPr lang="en-US" sz="1200" dirty="0"/>
           </a:p>
         </p:txBody>
       </p:sp>
@@ -9741,8 +9764,8 @@
         </p:nvSpPr>
         <p:spPr>
           <a:xfrm>
-            <a:off x="10058400" y="3337560"/>
-            <a:ext cx="1691640" cy="1417320"/>
+            <a:off x="10058400" y="3246120"/>
+            <a:ext cx="1691640" cy="1188720"/>
           </a:xfrm>
           <a:prstGeom prst="rect">
             <a:avLst/>
@@ -9761,7 +9784,7 @@
         </p:nvSpPr>
         <p:spPr>
           <a:xfrm>
-            <a:off x="10168128" y="3429000"/>
+            <a:off x="10168128" y="3319272"/>
             <a:ext cx="1463040" cy="201168"/>
           </a:xfrm>
           <a:prstGeom prst="rect">
@@ -9800,8 +9823,8 @@
         </p:nvSpPr>
         <p:spPr>
           <a:xfrm>
-            <a:off x="10168128" y="3657600"/>
-            <a:ext cx="1481328" cy="1005840"/>
+            <a:off x="10168128" y="3547872"/>
+            <a:ext cx="1481328" cy="868680"/>
           </a:xfrm>
           <a:prstGeom prst="rect">
             <a:avLst/>
@@ -9817,7 +9840,7 @@
               <a:buNone/>
             </a:pPr>
             <a:r>
-              <a:rPr lang="en-US" sz="1250" b="1" dirty="0">
+              <a:rPr lang="en-US" sz="1200" b="1" dirty="0">
                 <a:solidFill>
                   <a:srgbClr val="1A1D21"/>
                 </a:solidFill>
@@ -9827,7 +9850,7 @@
               </a:rPr>
               <a:t>Dispatch record</a:t>
             </a:r>
-            <a:endParaRPr lang="en-US" sz="1250" dirty="0"/>
+            <a:endParaRPr lang="en-US" sz="1200" dirty="0"/>
           </a:p>
           <a:p>
             <a:pPr indent="0" marL="0">
@@ -9844,36 +9867,226 @@
               </a:rPr>
               <a:t>Where each batch went</a:t>
             </a:r>
-            <a:endParaRPr lang="en-US" sz="1250" dirty="0"/>
-          </a:p>
-        </p:txBody>
-      </p:sp>
-      <p:sp>
-        <p:nvSpPr>
-          <p:cNvPr id="42" name="Text 40"/>
-          <p:cNvSpPr txBox="1"/>
-          <p:nvPr/>
-        </p:nvSpPr>
-        <p:spPr>
-          <a:xfrm>
-            <a:off x="548640" y="5349240"/>
-            <a:ext cx="10972800" cy="502920"/>
-          </a:xfrm>
-          <a:prstGeom prst="rect">
-            <a:avLst/>
-          </a:prstGeom>
-          <a:noFill/>
-          <a:ln/>
-        </p:spPr>
-        <p:txBody>
-          <a:bodyPr wrap="square" lIns="0" tIns="0" rIns="0" bIns="0" rtlCol="0" anchor="ctr"/>
-          <a:lstStyle/>
-          <a:p>
-            <a:pPr indent="0" marL="0">
-              <a:buNone/>
-            </a:pPr>
-            <a:r>
-              <a:rPr lang="en-US" sz="2200" i="1" dirty="0">
+            <a:endParaRPr lang="en-US" sz="1200" dirty="0"/>
+          </a:p>
+        </p:txBody>
+      </p:sp>
+      <p:sp>
+        <p:nvSpPr>
+          <p:cNvPr id="42" name="Shape 40"/>
+          <p:cNvSpPr/>
+          <p:nvPr/>
+        </p:nvSpPr>
+        <p:spPr>
+          <a:xfrm>
+            <a:off x="4334256" y="4544568"/>
+            <a:ext cx="2788920" cy="1305318"/>
+          </a:xfrm>
+          <a:prstGeom prst="rect">
+            <a:avLst/>
+          </a:prstGeom>
+          <a:solidFill>
+            <a:srgbClr val="FFFFFF"/>
+          </a:solidFill>
+          <a:ln w="9525">
+            <a:solidFill>
+              <a:srgbClr val="D6D8D6"/>
+            </a:solidFill>
+            <a:prstDash val="solid"/>
+          </a:ln>
+          <a:effectLst>
+            <a:outerShdw sx="100000" sy="100000" kx="0" ky="0" algn="bl" rotWithShape="0" blurRad="101600" dist="25400" dir="5400000">
+              <a:srgbClr val="000000">
+                <a:alpha val="18000"/>
+              </a:srgbClr>
+            </a:outerShdw>
+          </a:effectLst>
+        </p:spPr>
+      </p:sp>
+      <p:pic>
+        <p:nvPicPr>
+          <p:cNvPr id="43" name="Image 0" descr="/home/user/master-executive-system/sip-presentation/source/records/rec_process_params_11jun_c.jpg">    </p:cNvPr>
+          <p:cNvPicPr>
+            <a:picLocks noChangeAspect="1"/>
+          </p:cNvPicPr>
+          <p:nvPr/>
+        </p:nvPicPr>
+        <p:blipFill>
+          <a:blip r:embed="rId1"/>
+          <a:stretch>
+            <a:fillRect/>
+          </a:stretch>
+        </p:blipFill>
+        <p:spPr>
+          <a:xfrm>
+            <a:off x="4379976" y="4590288"/>
+            <a:ext cx="2697480" cy="1213878"/>
+          </a:xfrm>
+          <a:prstGeom prst="rect">
+            <a:avLst/>
+          </a:prstGeom>
+        </p:spPr>
+      </p:pic>
+      <p:sp>
+        <p:nvSpPr>
+          <p:cNvPr id="44" name="Text 41"/>
+          <p:cNvSpPr txBox="1"/>
+          <p:nvPr/>
+        </p:nvSpPr>
+        <p:spPr>
+          <a:xfrm>
+            <a:off x="4379976" y="5877318"/>
+            <a:ext cx="3017520" cy="201168"/>
+          </a:xfrm>
+          <a:prstGeom prst="rect">
+            <a:avLst/>
+          </a:prstGeom>
+          <a:noFill/>
+          <a:ln/>
+        </p:spPr>
+        <p:txBody>
+          <a:bodyPr wrap="square" lIns="0" tIns="0" rIns="0" bIns="0" rtlCol="0" anchor="ctr"/>
+          <a:lstStyle/>
+          <a:p>
+            <a:pPr indent="0" marL="0">
+              <a:buNone/>
+            </a:pPr>
+            <a:r>
+              <a:rPr lang="en-US" sz="850" i="1" dirty="0">
+                <a:solidFill>
+                  <a:srgbClr val="6B7278"/>
+                </a:solidFill>
+                <a:latin typeface="Calibri" pitchFamily="34" charset="0"/>
+                <a:ea typeface="Calibri" pitchFamily="34" charset="-122"/>
+                <a:cs typeface="Calibri" pitchFamily="34" charset="-120"/>
+              </a:rPr>
+              <a:t>At the machine: bristling process-parameter record, 11 Jun, shift A</a:t>
+            </a:r>
+            <a:endParaRPr lang="en-US" sz="850" dirty="0"/>
+          </a:p>
+        </p:txBody>
+      </p:sp>
+      <p:sp>
+        <p:nvSpPr>
+          <p:cNvPr id="45" name="Shape 42"/>
+          <p:cNvSpPr/>
+          <p:nvPr/>
+        </p:nvSpPr>
+        <p:spPr>
+          <a:xfrm>
+            <a:off x="8119872" y="4544568"/>
+            <a:ext cx="2788920" cy="1244603"/>
+          </a:xfrm>
+          <a:prstGeom prst="rect">
+            <a:avLst/>
+          </a:prstGeom>
+          <a:solidFill>
+            <a:srgbClr val="FFFFFF"/>
+          </a:solidFill>
+          <a:ln w="9525">
+            <a:solidFill>
+              <a:srgbClr val="D6D8D6"/>
+            </a:solidFill>
+            <a:prstDash val="solid"/>
+          </a:ln>
+          <a:effectLst>
+            <a:outerShdw sx="100000" sy="100000" kx="0" ky="0" algn="bl" rotWithShape="0" blurRad="101600" dist="25400" dir="5400000">
+              <a:srgbClr val="000000">
+                <a:alpha val="18000"/>
+              </a:srgbClr>
+            </a:outerShdw>
+          </a:effectLst>
+        </p:spPr>
+      </p:sp>
+      <p:pic>
+        <p:nvPicPr>
+          <p:cNvPr id="46" name="Image 1" descr="/home/user/master-executive-system/sip-presentation/source/records/rec_fg_production_13jun_c.jpg">    </p:cNvPr>
+          <p:cNvPicPr>
+            <a:picLocks noChangeAspect="1"/>
+          </p:cNvPicPr>
+          <p:nvPr/>
+        </p:nvPicPr>
+        <p:blipFill>
+          <a:blip r:embed="rId2"/>
+          <a:stretch>
+            <a:fillRect/>
+          </a:stretch>
+        </p:blipFill>
+        <p:spPr>
+          <a:xfrm>
+            <a:off x="8165592" y="4590288"/>
+            <a:ext cx="2697480" cy="1153163"/>
+          </a:xfrm>
+          <a:prstGeom prst="rect">
+            <a:avLst/>
+          </a:prstGeom>
+        </p:spPr>
+      </p:pic>
+      <p:sp>
+        <p:nvSpPr>
+          <p:cNvPr id="47" name="Text 43"/>
+          <p:cNvSpPr txBox="1"/>
+          <p:nvPr/>
+        </p:nvSpPr>
+        <p:spPr>
+          <a:xfrm>
+            <a:off x="8165592" y="5816603"/>
+            <a:ext cx="3017520" cy="201168"/>
+          </a:xfrm>
+          <a:prstGeom prst="rect">
+            <a:avLst/>
+          </a:prstGeom>
+          <a:noFill/>
+          <a:ln/>
+        </p:spPr>
+        <p:txBody>
+          <a:bodyPr wrap="square" lIns="0" tIns="0" rIns="0" bIns="0" rtlCol="0" anchor="ctr"/>
+          <a:lstStyle/>
+          <a:p>
+            <a:pPr indent="0" marL="0">
+              <a:buNone/>
+            </a:pPr>
+            <a:r>
+              <a:rPr lang="en-US" sz="850" i="1" dirty="0">
+                <a:solidFill>
+                  <a:srgbClr val="6B7278"/>
+                </a:solidFill>
+                <a:latin typeface="Calibri" pitchFamily="34" charset="0"/>
+                <a:ea typeface="Calibri" pitchFamily="34" charset="-122"/>
+                <a:cs typeface="Calibri" pitchFamily="34" charset="-120"/>
+              </a:rPr>
+              <a:t>After packing: FG production record, 13 Jun, shift A</a:t>
+            </a:r>
+            <a:endParaRPr lang="en-US" sz="850" dirty="0"/>
+          </a:p>
+        </p:txBody>
+      </p:sp>
+      <p:sp>
+        <p:nvSpPr>
+          <p:cNvPr id="48" name="Text 44"/>
+          <p:cNvSpPr txBox="1"/>
+          <p:nvPr/>
+        </p:nvSpPr>
+        <p:spPr>
+          <a:xfrm>
+            <a:off x="548640" y="6035040"/>
+            <a:ext cx="10972800" cy="411480"/>
+          </a:xfrm>
+          <a:prstGeom prst="rect">
+            <a:avLst/>
+          </a:prstGeom>
+          <a:noFill/>
+          <a:ln/>
+        </p:spPr>
+        <p:txBody>
+          <a:bodyPr wrap="square" lIns="0" tIns="0" rIns="0" bIns="0" rtlCol="0" anchor="ctr"/>
+          <a:lstStyle/>
+          <a:p>
+            <a:pPr indent="0" marL="0">
+              <a:buNone/>
+            </a:pPr>
+            <a:r>
+              <a:rPr lang="en-US" sz="2000" i="1" dirty="0">
                 <a:solidFill>
                   <a:srgbClr val="E0561F"/>
                 </a:solidFill>
@@ -9883,13 +10096,13 @@
               </a:rPr>
               <a:t>But those records did not automatically become one connected story.</a:t>
             </a:r>
-            <a:endParaRPr lang="en-US" sz="2200" dirty="0"/>
-          </a:p>
-        </p:txBody>
-      </p:sp>
-      <p:sp>
-        <p:nvSpPr>
-          <p:cNvPr id="44" name="Text 41"/>
+            <a:endParaRPr lang="en-US" sz="2000" dirty="0"/>
+          </a:p>
+        </p:txBody>
+      </p:sp>
+      <p:sp>
+        <p:nvSpPr>
+          <p:cNvPr id="50" name="Text 45"/>
           <p:cNvSpPr txBox="1"/>
           <p:nvPr/>
         </p:nvSpPr>
@@ -10310,46 +10523,303 @@
       </p:sp>
       <p:sp>
         <p:nvSpPr>
-          <p:cNvPr id="4" name="Shape 2"/>
+          <p:cNvPr id="4" name="Text 2"/>
+          <p:cNvSpPr txBox="1"/>
+          <p:nvPr/>
+        </p:nvSpPr>
+        <p:spPr>
+          <a:xfrm>
+            <a:off x="548640" y="1417320"/>
+            <a:ext cx="5669280" cy="228600"/>
+          </a:xfrm>
+          <a:prstGeom prst="rect">
+            <a:avLst/>
+          </a:prstGeom>
+          <a:noFill/>
+          <a:ln/>
+        </p:spPr>
+        <p:txBody>
+          <a:bodyPr wrap="square" lIns="0" tIns="0" rIns="0" bIns="0" rtlCol="0" anchor="ctr"/>
+          <a:lstStyle/>
+          <a:p>
+            <a:pPr indent="0" marL="0">
+              <a:buNone/>
+            </a:pPr>
+            <a:r>
+              <a:rPr lang="en-US" sz="950" b="1" spc="200" kern="0" dirty="0">
+                <a:solidFill>
+                  <a:srgbClr val="6B7278"/>
+                </a:solidFill>
+                <a:latin typeface="Calibri" pitchFamily="34" charset="0"/>
+                <a:ea typeface="Calibri" pitchFamily="34" charset="-122"/>
+                <a:cs typeface="Calibri" pitchFamily="34" charset="-120"/>
+              </a:rPr>
+              <a:t>PLANT RECORDS, AS I FOUND THEM  ·  JUNE 2026</a:t>
+            </a:r>
+            <a:endParaRPr lang="en-US" sz="950" dirty="0"/>
+          </a:p>
+        </p:txBody>
+      </p:sp>
+      <p:sp>
+        <p:nvSpPr>
+          <p:cNvPr id="5" name="Shape 3"/>
           <p:cNvSpPr/>
           <p:nvPr/>
         </p:nvSpPr>
         <p:spPr>
-          <a:xfrm rot="-120000">
-            <a:off x="640080" y="1828800"/>
-            <a:ext cx="2103120" cy="1097280"/>
+          <a:xfrm>
+            <a:off x="502920" y="1737360"/>
+            <a:ext cx="4297680" cy="2423317"/>
           </a:xfrm>
           <a:prstGeom prst="rect">
             <a:avLst/>
           </a:prstGeom>
           <a:solidFill>
-            <a:srgbClr val="F4F4F1"/>
+            <a:srgbClr val="FFFFFF"/>
           </a:solidFill>
-          <a:ln w="12700">
+          <a:ln w="9525">
             <a:solidFill>
-              <a:srgbClr val="B9BEC2"/>
+              <a:srgbClr val="D6D8D6"/>
             </a:solidFill>
             <a:prstDash val="solid"/>
           </a:ln>
           <a:effectLst>
-            <a:outerShdw sx="100000" sy="100000" kx="0" ky="0" algn="bl" rotWithShape="0" blurRad="50800" dist="25400" dir="5400000">
+            <a:outerShdw sx="100000" sy="100000" kx="0" ky="0" algn="bl" rotWithShape="0" blurRad="101600" dist="25400" dir="5400000">
               <a:srgbClr val="000000">
-                <a:alpha val="12000"/>
+                <a:alpha val="18000"/>
               </a:srgbClr>
             </a:outerShdw>
           </a:effectLst>
         </p:spPr>
       </p:sp>
-      <p:sp>
-        <p:nvSpPr>
-          <p:cNvPr id="5" name="Text 3"/>
-          <p:cNvSpPr txBox="1"/>
-          <p:nvPr/>
-        </p:nvSpPr>
-        <p:spPr>
-          <a:xfrm rot="-120000">
-            <a:off x="777240" y="1965960"/>
-            <a:ext cx="1828800" cy="822960"/>
+      <p:pic>
+        <p:nvPicPr>
+          <p:cNvPr id="6" name="Image 0" descr="/home/user/master-executive-system/sip-presentation/source/records/rec_traceability_p2_c.jpg">    </p:cNvPr>
+          <p:cNvPicPr>
+            <a:picLocks noChangeAspect="1"/>
+          </p:cNvPicPr>
+          <p:nvPr/>
+        </p:nvPicPr>
+        <p:blipFill>
+          <a:blip r:embed="rId1"/>
+          <a:stretch>
+            <a:fillRect/>
+          </a:stretch>
+        </p:blipFill>
+        <p:spPr>
+          <a:xfrm>
+            <a:off x="548640" y="1783080"/>
+            <a:ext cx="4206240" cy="2331877"/>
+          </a:xfrm>
+          <a:prstGeom prst="rect">
+            <a:avLst/>
+          </a:prstGeom>
+        </p:spPr>
+      </p:pic>
+      <p:sp>
+        <p:nvSpPr>
+          <p:cNvPr id="7" name="Shape 4"/>
+          <p:cNvSpPr/>
+          <p:nvPr/>
+        </p:nvSpPr>
+        <p:spPr>
+          <a:xfrm>
+            <a:off x="969264" y="2408023"/>
+            <a:ext cx="609905" cy="144576"/>
+          </a:xfrm>
+          <a:prstGeom prst="rect">
+            <a:avLst/>
+          </a:prstGeom>
+          <a:ln w="25400">
+            <a:solidFill>
+              <a:srgbClr val="E0561F"/>
+            </a:solidFill>
+            <a:prstDash val="solid"/>
+          </a:ln>
+        </p:spPr>
+      </p:sp>
+      <p:sp>
+        <p:nvSpPr>
+          <p:cNvPr id="8" name="Shape 5"/>
+          <p:cNvSpPr/>
+          <p:nvPr/>
+        </p:nvSpPr>
+        <p:spPr>
+          <a:xfrm>
+            <a:off x="3421502" y="2417351"/>
+            <a:ext cx="1261872" cy="116594"/>
+          </a:xfrm>
+          <a:prstGeom prst="rect">
+            <a:avLst/>
+          </a:prstGeom>
+          <a:ln w="25400">
+            <a:solidFill>
+              <a:srgbClr val="E0561F"/>
+            </a:solidFill>
+            <a:prstDash val="solid"/>
+          </a:ln>
+        </p:spPr>
+      </p:sp>
+      <p:sp>
+        <p:nvSpPr>
+          <p:cNvPr id="9" name="Shape 6"/>
+          <p:cNvSpPr/>
+          <p:nvPr/>
+        </p:nvSpPr>
+        <p:spPr>
+          <a:xfrm>
+            <a:off x="548640" y="3499342"/>
+            <a:ext cx="4206240" cy="226192"/>
+          </a:xfrm>
+          <a:prstGeom prst="rect">
+            <a:avLst/>
+          </a:prstGeom>
+          <a:ln w="25400">
+            <a:solidFill>
+              <a:srgbClr val="E0561F"/>
+            </a:solidFill>
+            <a:prstDash val="solid"/>
+          </a:ln>
+        </p:spPr>
+      </p:sp>
+      <p:sp>
+        <p:nvSpPr>
+          <p:cNvPr id="10" name="Shape 7"/>
+          <p:cNvSpPr/>
+          <p:nvPr/>
+        </p:nvSpPr>
+        <p:spPr>
+          <a:xfrm>
+            <a:off x="916229" y="2147274"/>
+            <a:ext cx="274320" cy="274320"/>
+          </a:xfrm>
+          <a:prstGeom prst="ellipse">
+            <a:avLst/>
+          </a:prstGeom>
+          <a:solidFill>
+            <a:srgbClr val="E0561F"/>
+          </a:solidFill>
+          <a:ln w="19050">
+            <a:solidFill>
+              <a:srgbClr val="FFFFFF"/>
+            </a:solidFill>
+            <a:prstDash val="solid"/>
+          </a:ln>
+        </p:spPr>
+      </p:sp>
+      <p:sp>
+        <p:nvSpPr>
+          <p:cNvPr id="11" name="Text 8"/>
+          <p:cNvSpPr txBox="1"/>
+          <p:nvPr/>
+        </p:nvSpPr>
+        <p:spPr>
+          <a:xfrm>
+            <a:off x="916229" y="2147274"/>
+            <a:ext cx="274320" cy="274320"/>
+          </a:xfrm>
+          <a:prstGeom prst="rect">
+            <a:avLst/>
+          </a:prstGeom>
+          <a:noFill/>
+          <a:ln/>
+        </p:spPr>
+        <p:txBody>
+          <a:bodyPr wrap="square" lIns="0" tIns="0" rIns="0" bIns="0" rtlCol="0" anchor="ctr"/>
+          <a:lstStyle/>
+          <a:p>
+            <a:pPr algn="ctr" indent="0" marL="0">
+              <a:buNone/>
+            </a:pPr>
+            <a:r>
+              <a:rPr lang="en-US" sz="1100" b="1" dirty="0">
+                <a:solidFill>
+                  <a:srgbClr val="FFFFFF"/>
+                </a:solidFill>
+                <a:latin typeface="Calibri" pitchFamily="34" charset="0"/>
+                <a:ea typeface="Calibri" pitchFamily="34" charset="-122"/>
+                <a:cs typeface="Calibri" pitchFamily="34" charset="-120"/>
+              </a:rPr>
+              <a:t>1</a:t>
+            </a:r>
+            <a:endParaRPr lang="en-US" sz="1100" dirty="0"/>
+          </a:p>
+        </p:txBody>
+      </p:sp>
+      <p:sp>
+        <p:nvSpPr>
+          <p:cNvPr id="12" name="Shape 9"/>
+          <p:cNvSpPr/>
+          <p:nvPr/>
+        </p:nvSpPr>
+        <p:spPr>
+          <a:xfrm>
+            <a:off x="4599432" y="3362182"/>
+            <a:ext cx="274320" cy="274320"/>
+          </a:xfrm>
+          <a:prstGeom prst="ellipse">
+            <a:avLst/>
+          </a:prstGeom>
+          <a:solidFill>
+            <a:srgbClr val="E0561F"/>
+          </a:solidFill>
+          <a:ln w="19050">
+            <a:solidFill>
+              <a:srgbClr val="FFFFFF"/>
+            </a:solidFill>
+            <a:prstDash val="solid"/>
+          </a:ln>
+        </p:spPr>
+      </p:sp>
+      <p:sp>
+        <p:nvSpPr>
+          <p:cNvPr id="13" name="Text 10"/>
+          <p:cNvSpPr txBox="1"/>
+          <p:nvPr/>
+        </p:nvSpPr>
+        <p:spPr>
+          <a:xfrm>
+            <a:off x="4599432" y="3362182"/>
+            <a:ext cx="274320" cy="274320"/>
+          </a:xfrm>
+          <a:prstGeom prst="rect">
+            <a:avLst/>
+          </a:prstGeom>
+          <a:noFill/>
+          <a:ln/>
+        </p:spPr>
+        <p:txBody>
+          <a:bodyPr wrap="square" lIns="0" tIns="0" rIns="0" bIns="0" rtlCol="0" anchor="ctr"/>
+          <a:lstStyle/>
+          <a:p>
+            <a:pPr algn="ctr" indent="0" marL="0">
+              <a:buNone/>
+            </a:pPr>
+            <a:r>
+              <a:rPr lang="en-US" sz="1100" b="1" dirty="0">
+                <a:solidFill>
+                  <a:srgbClr val="FFFFFF"/>
+                </a:solidFill>
+                <a:latin typeface="Calibri" pitchFamily="34" charset="0"/>
+                <a:ea typeface="Calibri" pitchFamily="34" charset="-122"/>
+                <a:cs typeface="Calibri" pitchFamily="34" charset="-120"/>
+              </a:rPr>
+              <a:t>2</a:t>
+            </a:r>
+            <a:endParaRPr lang="en-US" sz="1100" dirty="0"/>
+          </a:p>
+        </p:txBody>
+      </p:sp>
+      <p:sp>
+        <p:nvSpPr>
+          <p:cNvPr id="14" name="Text 11"/>
+          <p:cNvSpPr txBox="1"/>
+          <p:nvPr/>
+        </p:nvSpPr>
+        <p:spPr>
+          <a:xfrm>
+            <a:off x="4919472" y="1783080"/>
+            <a:ext cx="1417320" cy="2377440"/>
           </a:xfrm>
           <a:prstGeom prst="rect">
             <a:avLst/>
@@ -10365,7 +10835,7 @@
               <a:buNone/>
             </a:pPr>
             <a:r>
-              <a:rPr lang="en-US" sz="1600" b="1" dirty="0">
+              <a:rPr lang="en-US" sz="1000" b="1" dirty="0">
                 <a:solidFill>
                   <a:srgbClr val="1A1D21"/>
                 </a:solidFill>
@@ -10373,247 +10843,178 @@
                 <a:ea typeface="Calibri" pitchFamily="34" charset="-122"/>
                 <a:cs typeface="Calibri" pitchFamily="34" charset="-120"/>
               </a:rPr>
-              <a:t>Production</a:t>
-            </a:r>
-            <a:endParaRPr lang="en-US" sz="1600" dirty="0"/>
-          </a:p>
-          <a:p>
-            <a:pPr indent="0" marL="0">
-              <a:buNone/>
-            </a:pPr>
-            <a:r>
-              <a:rPr lang="en-US" sz="1100" dirty="0">
-                <a:solidFill>
-                  <a:srgbClr val="6B7278"/>
-                </a:solidFill>
-                <a:latin typeface="Calibri" pitchFamily="34" charset="0"/>
-                <a:ea typeface="Calibri" pitchFamily="34" charset="-122"/>
-                <a:cs typeface="Calibri" pitchFamily="34" charset="-120"/>
-              </a:rPr>
-              <a:t>Output, shift, line</a:t>
-            </a:r>
-            <a:endParaRPr lang="en-US" sz="1600" dirty="0"/>
-          </a:p>
-        </p:txBody>
-      </p:sp>
-      <p:sp>
-        <p:nvSpPr>
-          <p:cNvPr id="6" name="Shape 4"/>
+              <a:t>Traceability report, bristling. </a:t>
+            </a:r>
+            <a:pPr indent="0" marL="0">
+              <a:buNone/>
+            </a:pPr>
+            <a:r>
+              <a:rPr lang="en-US" sz="1000" dirty="0">
+                <a:solidFill>
+                  <a:srgbClr val="3E4750"/>
+                </a:solidFill>
+                <a:latin typeface="Calibri" pitchFamily="34" charset="0"/>
+                <a:ea typeface="Calibri" pitchFamily="34" charset="-122"/>
+                <a:cs typeface="Calibri" pitchFamily="34" charset="-120"/>
+              </a:rPr>
+              <a:t>Its own headers say where each column comes from: the handle tag, the cap tag, incoming analytical reports, shift production formats. It is compiled by hand.</a:t>
+            </a:r>
+            <a:endParaRPr lang="en-US" sz="1000" dirty="0"/>
+          </a:p>
+        </p:txBody>
+      </p:sp>
+      <p:sp>
+        <p:nvSpPr>
+          <p:cNvPr id="15" name="Shape 12"/>
           <p:cNvSpPr/>
           <p:nvPr/>
         </p:nvSpPr>
         <p:spPr>
-          <a:xfrm rot="180000">
-            <a:off x="2971800" y="2148840"/>
-            <a:ext cx="2103120" cy="1097280"/>
+          <a:xfrm>
+            <a:off x="502920" y="4325112"/>
+            <a:ext cx="3291840" cy="1409616"/>
           </a:xfrm>
           <a:prstGeom prst="rect">
             <a:avLst/>
           </a:prstGeom>
           <a:solidFill>
-            <a:srgbClr val="F4F4F1"/>
+            <a:srgbClr val="FFFFFF"/>
           </a:solidFill>
-          <a:ln w="12700">
+          <a:ln w="9525">
             <a:solidFill>
-              <a:srgbClr val="B9BEC2"/>
+              <a:srgbClr val="D6D8D6"/>
             </a:solidFill>
             <a:prstDash val="solid"/>
           </a:ln>
           <a:effectLst>
-            <a:outerShdw sx="100000" sy="100000" kx="0" ky="0" algn="bl" rotWithShape="0" blurRad="50800" dist="25400" dir="5400000">
+            <a:outerShdw sx="100000" sy="100000" kx="0" ky="0" algn="bl" rotWithShape="0" blurRad="101600" dist="25400" dir="5400000">
               <a:srgbClr val="000000">
-                <a:alpha val="12000"/>
+                <a:alpha val="18000"/>
               </a:srgbClr>
             </a:outerShdw>
           </a:effectLst>
         </p:spPr>
       </p:sp>
-      <p:sp>
-        <p:nvSpPr>
-          <p:cNvPr id="7" name="Text 5"/>
-          <p:cNvSpPr txBox="1"/>
-          <p:nvPr/>
-        </p:nvSpPr>
-        <p:spPr>
-          <a:xfrm rot="180000">
-            <a:off x="3108960" y="2286000"/>
-            <a:ext cx="1828800" cy="822960"/>
-          </a:xfrm>
-          <a:prstGeom prst="rect">
-            <a:avLst/>
-          </a:prstGeom>
-          <a:noFill/>
-          <a:ln/>
-        </p:spPr>
-        <p:txBody>
-          <a:bodyPr wrap="square" lIns="0" tIns="0" rIns="0" bIns="0" rtlCol="0" anchor="t"/>
-          <a:lstStyle/>
-          <a:p>
-            <a:pPr indent="0" marL="0">
-              <a:buNone/>
-            </a:pPr>
-            <a:r>
-              <a:rPr lang="en-US" sz="1600" b="1" dirty="0">
-                <a:solidFill>
-                  <a:srgbClr val="1A1D21"/>
-                </a:solidFill>
-                <a:latin typeface="Calibri" pitchFamily="34" charset="0"/>
-                <a:ea typeface="Calibri" pitchFamily="34" charset="-122"/>
-                <a:cs typeface="Calibri" pitchFamily="34" charset="-120"/>
-              </a:rPr>
-              <a:t>Quality</a:t>
-            </a:r>
-            <a:endParaRPr lang="en-US" sz="1600" dirty="0"/>
-          </a:p>
-          <a:p>
-            <a:pPr indent="0" marL="0">
-              <a:buNone/>
-            </a:pPr>
-            <a:r>
-              <a:rPr lang="en-US" sz="1100" dirty="0">
-                <a:solidFill>
-                  <a:srgbClr val="6B7278"/>
-                </a:solidFill>
-                <a:latin typeface="Calibri" pitchFamily="34" charset="0"/>
-                <a:ea typeface="Calibri" pitchFamily="34" charset="-122"/>
-                <a:cs typeface="Calibri" pitchFamily="34" charset="-120"/>
-              </a:rPr>
-              <a:t>Checks, rejections</a:t>
-            </a:r>
-            <a:endParaRPr lang="en-US" sz="1600" dirty="0"/>
-          </a:p>
-        </p:txBody>
-      </p:sp>
-      <p:sp>
-        <p:nvSpPr>
-          <p:cNvPr id="8" name="Shape 6"/>
+      <p:pic>
+        <p:nvPicPr>
+          <p:cNvPr id="16" name="Image 1" descr="/home/user/master-executive-system/sip-presentation/source/records/rec_fg_production_11jun_c.jpg">    </p:cNvPr>
+          <p:cNvPicPr>
+            <a:picLocks noChangeAspect="1"/>
+          </p:cNvPicPr>
+          <p:nvPr/>
+        </p:nvPicPr>
+        <p:blipFill>
+          <a:blip r:embed="rId2"/>
+          <a:stretch>
+            <a:fillRect/>
+          </a:stretch>
+        </p:blipFill>
+        <p:spPr>
+          <a:xfrm>
+            <a:off x="548640" y="4370832"/>
+            <a:ext cx="3200400" cy="1318176"/>
+          </a:xfrm>
+          <a:prstGeom prst="rect">
+            <a:avLst/>
+          </a:prstGeom>
+        </p:spPr>
+      </p:pic>
+      <p:sp>
+        <p:nvSpPr>
+          <p:cNvPr id="17" name="Shape 13"/>
           <p:cNvSpPr/>
           <p:nvPr/>
         </p:nvSpPr>
         <p:spPr>
-          <a:xfrm rot="120000">
-            <a:off x="868680" y="3429000"/>
-            <a:ext cx="2103120" cy="1097280"/>
-          </a:xfrm>
-          <a:prstGeom prst="rect">
-            <a:avLst/>
-          </a:prstGeom>
-          <a:solidFill>
-            <a:srgbClr val="F4F4F1"/>
-          </a:solidFill>
-          <a:ln w="12700">
+          <a:xfrm>
+            <a:off x="836676" y="5174919"/>
+            <a:ext cx="2720340" cy="125227"/>
+          </a:xfrm>
+          <a:prstGeom prst="rect">
+            <a:avLst/>
+          </a:prstGeom>
+          <a:ln w="25400">
             <a:solidFill>
-              <a:srgbClr val="B9BEC2"/>
+              <a:srgbClr val="E0561F"/>
             </a:solidFill>
             <a:prstDash val="solid"/>
           </a:ln>
-          <a:effectLst>
-            <a:outerShdw sx="100000" sy="100000" kx="0" ky="0" algn="bl" rotWithShape="0" blurRad="50800" dist="25400" dir="5400000">
-              <a:srgbClr val="000000">
-                <a:alpha val="12000"/>
-              </a:srgbClr>
-            </a:outerShdw>
-          </a:effectLst>
-        </p:spPr>
-      </p:sp>
-      <p:sp>
-        <p:nvSpPr>
-          <p:cNvPr id="9" name="Text 7"/>
-          <p:cNvSpPr txBox="1"/>
-          <p:nvPr/>
-        </p:nvSpPr>
-        <p:spPr>
-          <a:xfrm rot="120000">
-            <a:off x="1005840" y="3566160"/>
-            <a:ext cx="1828800" cy="822960"/>
-          </a:xfrm>
-          <a:prstGeom prst="rect">
-            <a:avLst/>
-          </a:prstGeom>
-          <a:noFill/>
-          <a:ln/>
-        </p:spPr>
-        <p:txBody>
-          <a:bodyPr wrap="square" lIns="0" tIns="0" rIns="0" bIns="0" rtlCol="0" anchor="t"/>
-          <a:lstStyle/>
-          <a:p>
-            <a:pPr indent="0" marL="0">
-              <a:buNone/>
-            </a:pPr>
-            <a:r>
-              <a:rPr lang="en-US" sz="1600" b="1" dirty="0">
-                <a:solidFill>
-                  <a:srgbClr val="1A1D21"/>
-                </a:solidFill>
-                <a:latin typeface="Calibri" pitchFamily="34" charset="0"/>
-                <a:ea typeface="Calibri" pitchFamily="34" charset="-122"/>
-                <a:cs typeface="Calibri" pitchFamily="34" charset="-120"/>
-              </a:rPr>
-              <a:t>Material</a:t>
-            </a:r>
-            <a:endParaRPr lang="en-US" sz="1600" dirty="0"/>
-          </a:p>
-          <a:p>
-            <a:pPr indent="0" marL="0">
-              <a:buNone/>
-            </a:pPr>
-            <a:r>
-              <a:rPr lang="en-US" sz="1100" dirty="0">
-                <a:solidFill>
-                  <a:srgbClr val="6B7278"/>
-                </a:solidFill>
-                <a:latin typeface="Calibri" pitchFamily="34" charset="0"/>
-                <a:ea typeface="Calibri" pitchFamily="34" charset="-122"/>
-                <a:cs typeface="Calibri" pitchFamily="34" charset="-120"/>
-              </a:rPr>
-              <a:t>Lots issued</a:t>
-            </a:r>
-            <a:endParaRPr lang="en-US" sz="1600" dirty="0"/>
-          </a:p>
-        </p:txBody>
-      </p:sp>
-      <p:sp>
-        <p:nvSpPr>
-          <p:cNvPr id="10" name="Shape 8"/>
+        </p:spPr>
+      </p:sp>
+      <p:sp>
+        <p:nvSpPr>
+          <p:cNvPr id="18" name="Shape 14"/>
           <p:cNvSpPr/>
           <p:nvPr/>
         </p:nvSpPr>
         <p:spPr>
-          <a:xfrm rot="-180000">
-            <a:off x="3246120" y="3657600"/>
-            <a:ext cx="2103120" cy="1097280"/>
-          </a:xfrm>
-          <a:prstGeom prst="rect">
+          <a:xfrm>
+            <a:off x="3593592" y="5037759"/>
+            <a:ext cx="274320" cy="274320"/>
+          </a:xfrm>
+          <a:prstGeom prst="ellipse">
             <a:avLst/>
           </a:prstGeom>
           <a:solidFill>
-            <a:srgbClr val="F4F4F1"/>
+            <a:srgbClr val="E0561F"/>
           </a:solidFill>
-          <a:ln w="12700">
+          <a:ln w="19050">
             <a:solidFill>
-              <a:srgbClr val="B9BEC2"/>
+              <a:srgbClr val="FFFFFF"/>
             </a:solidFill>
             <a:prstDash val="solid"/>
           </a:ln>
-          <a:effectLst>
-            <a:outerShdw sx="100000" sy="100000" kx="0" ky="0" algn="bl" rotWithShape="0" blurRad="50800" dist="25400" dir="5400000">
-              <a:srgbClr val="000000">
-                <a:alpha val="12000"/>
-              </a:srgbClr>
-            </a:outerShdw>
-          </a:effectLst>
-        </p:spPr>
-      </p:sp>
-      <p:sp>
-        <p:nvSpPr>
-          <p:cNvPr id="11" name="Text 9"/>
-          <p:cNvSpPr txBox="1"/>
-          <p:nvPr/>
-        </p:nvSpPr>
-        <p:spPr>
-          <a:xfrm rot="-180000">
-            <a:off x="3383280" y="3794760"/>
-            <a:ext cx="1828800" cy="822960"/>
+        </p:spPr>
+      </p:sp>
+      <p:sp>
+        <p:nvSpPr>
+          <p:cNvPr id="19" name="Text 15"/>
+          <p:cNvSpPr txBox="1"/>
+          <p:nvPr/>
+        </p:nvSpPr>
+        <p:spPr>
+          <a:xfrm>
+            <a:off x="3593592" y="5037759"/>
+            <a:ext cx="274320" cy="274320"/>
+          </a:xfrm>
+          <a:prstGeom prst="rect">
+            <a:avLst/>
+          </a:prstGeom>
+          <a:noFill/>
+          <a:ln/>
+        </p:spPr>
+        <p:txBody>
+          <a:bodyPr wrap="square" lIns="0" tIns="0" rIns="0" bIns="0" rtlCol="0" anchor="ctr"/>
+          <a:lstStyle/>
+          <a:p>
+            <a:pPr algn="ctr" indent="0" marL="0">
+              <a:buNone/>
+            </a:pPr>
+            <a:r>
+              <a:rPr lang="en-US" sz="1100" b="1" dirty="0">
+                <a:solidFill>
+                  <a:srgbClr val="FFFFFF"/>
+                </a:solidFill>
+                <a:latin typeface="Calibri" pitchFamily="34" charset="0"/>
+                <a:ea typeface="Calibri" pitchFamily="34" charset="-122"/>
+                <a:cs typeface="Calibri" pitchFamily="34" charset="-120"/>
+              </a:rPr>
+              <a:t>2</a:t>
+            </a:r>
+            <a:endParaRPr lang="en-US" sz="1100" dirty="0"/>
+          </a:p>
+        </p:txBody>
+      </p:sp>
+      <p:sp>
+        <p:nvSpPr>
+          <p:cNvPr id="20" name="Text 16"/>
+          <p:cNvSpPr txBox="1"/>
+          <p:nvPr/>
+        </p:nvSpPr>
+        <p:spPr>
+          <a:xfrm>
+            <a:off x="3977640" y="4370832"/>
+            <a:ext cx="2331720" cy="1188720"/>
           </a:xfrm>
           <a:prstGeom prst="rect">
             <a:avLst/>
@@ -10629,7 +11030,74 @@
               <a:buNone/>
             </a:pPr>
             <a:r>
-              <a:rPr lang="en-US" sz="1600" b="1" dirty="0">
+              <a:rPr lang="en-US" sz="1050" b="1" dirty="0">
+                <a:solidFill>
+                  <a:srgbClr val="E0561F"/>
+                </a:solidFill>
+                <a:latin typeface="Calibri" pitchFamily="34" charset="0"/>
+                <a:ea typeface="Calibri" pitchFamily="34" charset="-122"/>
+                <a:cs typeface="Calibri" pitchFamily="34" charset="-120"/>
+              </a:rPr>
+              <a:t>Written twice. </a:t>
+            </a:r>
+            <a:pPr indent="0" marL="0">
+              <a:buNone/>
+            </a:pPr>
+            <a:r>
+              <a:rPr lang="en-US" sz="1050" dirty="0">
+                <a:solidFill>
+                  <a:srgbClr val="3E4750"/>
+                </a:solidFill>
+                <a:latin typeface="Calibri" pitchFamily="34" charset="0"/>
+                <a:ea typeface="Calibri" pitchFamily="34" charset="-122"/>
+                <a:cs typeface="Calibri" pitchFamily="34" charset="-120"/>
+              </a:rPr>
+              <a:t>11 June, JBCA260003, 25 cases: on the FG production record, and again in row 19 of the traceability report.</a:t>
+            </a:r>
+            <a:endParaRPr lang="en-US" sz="1050" dirty="0"/>
+          </a:p>
+        </p:txBody>
+      </p:sp>
+      <p:sp>
+        <p:nvSpPr>
+          <p:cNvPr id="21" name="Text 17"/>
+          <p:cNvSpPr txBox="1"/>
+          <p:nvPr/>
+        </p:nvSpPr>
+        <p:spPr>
+          <a:xfrm>
+            <a:off x="548640" y="5897880"/>
+            <a:ext cx="5760720" cy="411480"/>
+          </a:xfrm>
+          <a:prstGeom prst="rect">
+            <a:avLst/>
+          </a:prstGeom>
+          <a:noFill/>
+          <a:ln/>
+        </p:spPr>
+        <p:txBody>
+          <a:bodyPr wrap="square" lIns="0" tIns="0" rIns="0" bIns="0" rtlCol="0" anchor="ctr"/>
+          <a:lstStyle/>
+          <a:p>
+            <a:pPr indent="0" marL="0">
+              <a:buNone/>
+            </a:pPr>
+            <a:r>
+              <a:rPr lang="en-US" sz="900" b="1" spc="200" kern="0" dirty="0">
+                <a:solidFill>
+                  <a:srgbClr val="6B7278"/>
+                </a:solidFill>
+                <a:latin typeface="Calibri" pitchFamily="34" charset="0"/>
+                <a:ea typeface="Calibri" pitchFamily="34" charset="-122"/>
+                <a:cs typeface="Calibri" pitchFamily="34" charset="-120"/>
+              </a:rPr>
+              <a:t>SEPARATE REGISTERS  </a:t>
+            </a:r>
+            <a:pPr indent="0" marL="0">
+              <a:buNone/>
+            </a:pPr>
+            <a:r>
+              <a:rPr lang="en-US" sz="1150" dirty="0">
                 <a:solidFill>
                   <a:srgbClr val="1A1D21"/>
                 </a:solidFill>
@@ -10637,159 +11105,15 @@
                 <a:ea typeface="Calibri" pitchFamily="34" charset="-122"/>
                 <a:cs typeface="Calibri" pitchFamily="34" charset="-120"/>
               </a:rPr>
-              <a:t>Downtime</a:t>
-            </a:r>
-            <a:endParaRPr lang="en-US" sz="1600" dirty="0"/>
-          </a:p>
-          <a:p>
-            <a:pPr indent="0" marL="0">
-              <a:buNone/>
-            </a:pPr>
-            <a:r>
-              <a:rPr lang="en-US" sz="1100" dirty="0">
-                <a:solidFill>
-                  <a:srgbClr val="6B7278"/>
-                </a:solidFill>
-                <a:latin typeface="Calibri" pitchFamily="34" charset="0"/>
-                <a:ea typeface="Calibri" pitchFamily="34" charset="-122"/>
-                <a:cs typeface="Calibri" pitchFamily="34" charset="-120"/>
-              </a:rPr>
-              <a:t>Stops &amp; reasons</a:t>
-            </a:r>
-            <a:endParaRPr lang="en-US" sz="1600" dirty="0"/>
-          </a:p>
-        </p:txBody>
-      </p:sp>
-      <p:sp>
-        <p:nvSpPr>
-          <p:cNvPr id="12" name="Shape 10"/>
-          <p:cNvSpPr/>
-          <p:nvPr/>
-        </p:nvSpPr>
-        <p:spPr>
-          <a:xfrm rot="60000">
-            <a:off x="1920240" y="4846320"/>
-            <a:ext cx="2103120" cy="1097280"/>
-          </a:xfrm>
-          <a:prstGeom prst="rect">
-            <a:avLst/>
-          </a:prstGeom>
-          <a:solidFill>
-            <a:srgbClr val="F4F4F1"/>
-          </a:solidFill>
-          <a:ln w="12700">
-            <a:solidFill>
-              <a:srgbClr val="B9BEC2"/>
-            </a:solidFill>
-            <a:prstDash val="solid"/>
-          </a:ln>
-          <a:effectLst>
-            <a:outerShdw sx="100000" sy="100000" kx="0" ky="0" algn="bl" rotWithShape="0" blurRad="50800" dist="25400" dir="5400000">
-              <a:srgbClr val="000000">
-                <a:alpha val="12000"/>
-              </a:srgbClr>
-            </a:outerShdw>
-          </a:effectLst>
-        </p:spPr>
-      </p:sp>
-      <p:sp>
-        <p:nvSpPr>
-          <p:cNvPr id="13" name="Text 11"/>
-          <p:cNvSpPr txBox="1"/>
-          <p:nvPr/>
-        </p:nvSpPr>
-        <p:spPr>
-          <a:xfrm rot="60000">
-            <a:off x="2057400" y="4983480"/>
-            <a:ext cx="1828800" cy="822960"/>
-          </a:xfrm>
-          <a:prstGeom prst="rect">
-            <a:avLst/>
-          </a:prstGeom>
-          <a:noFill/>
-          <a:ln/>
-        </p:spPr>
-        <p:txBody>
-          <a:bodyPr wrap="square" lIns="0" tIns="0" rIns="0" bIns="0" rtlCol="0" anchor="t"/>
-          <a:lstStyle/>
-          <a:p>
-            <a:pPr indent="0" marL="0">
-              <a:buNone/>
-            </a:pPr>
-            <a:r>
-              <a:rPr lang="en-US" sz="1600" b="1" dirty="0">
-                <a:solidFill>
-                  <a:srgbClr val="1A1D21"/>
-                </a:solidFill>
-                <a:latin typeface="Calibri" pitchFamily="34" charset="0"/>
-                <a:ea typeface="Calibri" pitchFamily="34" charset="-122"/>
-                <a:cs typeface="Calibri" pitchFamily="34" charset="-120"/>
-              </a:rPr>
-              <a:t>Dispatch</a:t>
-            </a:r>
-            <a:endParaRPr lang="en-US" sz="1600" dirty="0"/>
-          </a:p>
-          <a:p>
-            <a:pPr indent="0" marL="0">
-              <a:buNone/>
-            </a:pPr>
-            <a:r>
-              <a:rPr lang="en-US" sz="1100" dirty="0">
-                <a:solidFill>
-                  <a:srgbClr val="6B7278"/>
-                </a:solidFill>
-                <a:latin typeface="Calibri" pitchFamily="34" charset="0"/>
-                <a:ea typeface="Calibri" pitchFamily="34" charset="-122"/>
-                <a:cs typeface="Calibri" pitchFamily="34" charset="-120"/>
-              </a:rPr>
-              <a:t>Customer, quantity</a:t>
-            </a:r>
-            <a:endParaRPr lang="en-US" sz="1600" dirty="0"/>
-          </a:p>
-        </p:txBody>
-      </p:sp>
-      <p:sp>
-        <p:nvSpPr>
-          <p:cNvPr id="14" name="Text 12"/>
-          <p:cNvSpPr txBox="1"/>
-          <p:nvPr/>
-        </p:nvSpPr>
-        <p:spPr>
-          <a:xfrm>
-            <a:off x="640080" y="6172200"/>
-            <a:ext cx="3657600" cy="274320"/>
-          </a:xfrm>
-          <a:prstGeom prst="rect">
-            <a:avLst/>
-          </a:prstGeom>
-          <a:noFill/>
-          <a:ln/>
-        </p:spPr>
-        <p:txBody>
-          <a:bodyPr wrap="square" lIns="0" tIns="0" rIns="0" bIns="0" rtlCol="0" anchor="ctr"/>
-          <a:lstStyle/>
-          <a:p>
-            <a:pPr indent="0" marL="0">
-              <a:buNone/>
-            </a:pPr>
-            <a:r>
-              <a:rPr lang="en-US" sz="1000" i="1" dirty="0">
-                <a:solidFill>
-                  <a:srgbClr val="6B7278"/>
-                </a:solidFill>
-                <a:latin typeface="Calibri" pitchFamily="34" charset="0"/>
-                <a:ea typeface="Calibri" pitchFamily="34" charset="-122"/>
-                <a:cs typeface="Calibri" pitchFamily="34" charset="-120"/>
-              </a:rPr>
-              <a:t>Separate registers</a:t>
-            </a:r>
-            <a:endParaRPr lang="en-US" sz="1000" dirty="0"/>
-          </a:p>
-        </p:txBody>
-      </p:sp>
-      <p:sp>
-        <p:nvSpPr>
-          <p:cNvPr id="15" name="Shape 13"/>
+              <a:t>Production · Quality · Material · Downtime · Dispatch, each kept by its own function</a:t>
+            </a:r>
+            <a:endParaRPr lang="en-US" sz="900" dirty="0"/>
+          </a:p>
+        </p:txBody>
+      </p:sp>
+      <p:sp>
+        <p:nvSpPr>
+          <p:cNvPr id="22" name="Shape 18"/>
           <p:cNvSpPr/>
           <p:nvPr/>
         </p:nvSpPr>
@@ -10809,7 +11133,7 @@
       </p:sp>
       <p:sp>
         <p:nvSpPr>
-          <p:cNvPr id="16" name="Text 14"/>
+          <p:cNvPr id="23" name="Text 19"/>
           <p:cNvSpPr txBox="1"/>
           <p:nvPr/>
         </p:nvSpPr>
@@ -10848,7 +11172,7 @@
       </p:sp>
       <p:sp>
         <p:nvSpPr>
-          <p:cNvPr id="17" name="Text 15"/>
+          <p:cNvPr id="24" name="Text 20"/>
           <p:cNvSpPr txBox="1"/>
           <p:nvPr/>
         </p:nvSpPr>
@@ -10887,7 +11211,7 @@
       </p:sp>
       <p:sp>
         <p:nvSpPr>
-          <p:cNvPr id="18" name="Shape 16"/>
+          <p:cNvPr id="25" name="Shape 21"/>
           <p:cNvSpPr/>
           <p:nvPr/>
         </p:nvSpPr>
@@ -10907,7 +11231,7 @@
       </p:sp>
       <p:sp>
         <p:nvSpPr>
-          <p:cNvPr id="19" name="Text 17"/>
+          <p:cNvPr id="26" name="Text 22"/>
           <p:cNvSpPr txBox="1"/>
           <p:nvPr/>
         </p:nvSpPr>
@@ -10946,7 +11270,7 @@
       </p:sp>
       <p:sp>
         <p:nvSpPr>
-          <p:cNvPr id="20" name="Text 18"/>
+          <p:cNvPr id="27" name="Text 23"/>
           <p:cNvSpPr txBox="1"/>
           <p:nvPr/>
         </p:nvSpPr>
@@ -10985,7 +11309,7 @@
       </p:sp>
       <p:sp>
         <p:nvSpPr>
-          <p:cNvPr id="21" name="Shape 19"/>
+          <p:cNvPr id="28" name="Shape 24"/>
           <p:cNvSpPr/>
           <p:nvPr/>
         </p:nvSpPr>
@@ -11005,7 +11329,7 @@
       </p:sp>
       <p:sp>
         <p:nvSpPr>
-          <p:cNvPr id="22" name="Text 20"/>
+          <p:cNvPr id="29" name="Text 25"/>
           <p:cNvSpPr txBox="1"/>
           <p:nvPr/>
         </p:nvSpPr>
@@ -11044,7 +11368,7 @@
       </p:sp>
       <p:sp>
         <p:nvSpPr>
-          <p:cNvPr id="23" name="Text 21"/>
+          <p:cNvPr id="30" name="Text 26"/>
           <p:cNvSpPr txBox="1"/>
           <p:nvPr/>
         </p:nvSpPr>
@@ -11083,7 +11407,7 @@
       </p:sp>
       <p:sp>
         <p:nvSpPr>
-          <p:cNvPr id="24" name="Shape 22"/>
+          <p:cNvPr id="31" name="Shape 27"/>
           <p:cNvSpPr/>
           <p:nvPr/>
         </p:nvSpPr>
@@ -11103,7 +11427,7 @@
       </p:sp>
       <p:sp>
         <p:nvSpPr>
-          <p:cNvPr id="25" name="Text 23"/>
+          <p:cNvPr id="32" name="Text 28"/>
           <p:cNvSpPr txBox="1"/>
           <p:nvPr/>
         </p:nvSpPr>
@@ -11142,7 +11466,7 @@
       </p:sp>
       <p:sp>
         <p:nvSpPr>
-          <p:cNvPr id="26" name="Text 24"/>
+          <p:cNvPr id="33" name="Text 29"/>
           <p:cNvSpPr txBox="1"/>
           <p:nvPr/>
         </p:nvSpPr>
@@ -11198,7 +11522,7 @@
       </p:sp>
       <p:sp>
         <p:nvSpPr>
-          <p:cNvPr id="27" name="Text 25"/>
+          <p:cNvPr id="34" name="Text 30"/>
           <p:cNvSpPr txBox="1"/>
           <p:nvPr/>
         </p:nvSpPr>
@@ -11345,7 +11669,7 @@
                 <a:ea typeface="Calibri" pitchFamily="34" charset="-122"/>
                 <a:cs typeface="Calibri" pitchFamily="34" charset="-120"/>
               </a:rPr>
-              <a:t>Main toothpaste line, paste plant</a:t>
+              <a:t>Tube filling line, paste plant</a:t>
             </a:r>
             <a:endParaRPr lang="en-US" sz="1000" dirty="0"/>
           </a:p>
@@ -15221,7 +15545,7 @@
         <p:spPr>
           <a:xfrm>
             <a:off x="548640" y="1691640"/>
-            <a:ext cx="6766560" cy="786384"/>
+            <a:ext cx="6172200" cy="786384"/>
           </a:xfrm>
           <a:prstGeom prst="rect">
             <a:avLst/>
@@ -15241,7 +15565,7 @@
         <p:spPr>
           <a:xfrm>
             <a:off x="822960" y="1691640"/>
-            <a:ext cx="3108960" cy="786384"/>
+            <a:ext cx="2834640" cy="786384"/>
           </a:xfrm>
           <a:prstGeom prst="rect">
             <a:avLst/>
@@ -15279,24 +15603,24 @@
         </p:nvSpPr>
         <p:spPr>
           <a:xfrm>
-            <a:off x="3840480" y="1691640"/>
-            <a:ext cx="3291840" cy="786384"/>
-          </a:xfrm>
-          <a:prstGeom prst="rect">
-            <a:avLst/>
-          </a:prstGeom>
-          <a:noFill/>
-          <a:ln/>
-        </p:spPr>
-        <p:txBody>
-          <a:bodyPr wrap="square" lIns="0" tIns="0" rIns="0" bIns="0" rtlCol="0" anchor="ctr"/>
-          <a:lstStyle/>
-          <a:p>
-            <a:pPr indent="0" marL="0">
-              <a:buNone/>
-            </a:pPr>
-            <a:r>
-              <a:rPr lang="en-US" sz="1150" dirty="0">
+            <a:off x="3611880" y="1691640"/>
+            <a:ext cx="2971800" cy="786384"/>
+          </a:xfrm>
+          <a:prstGeom prst="rect">
+            <a:avLst/>
+          </a:prstGeom>
+          <a:noFill/>
+          <a:ln/>
+        </p:spPr>
+        <p:txBody>
+          <a:bodyPr wrap="square" lIns="0" tIns="0" rIns="0" bIns="0" rtlCol="0" anchor="ctr"/>
+          <a:lstStyle/>
+          <a:p>
+            <a:pPr indent="0" marL="0">
+              <a:buNone/>
+            </a:pPr>
+            <a:r>
+              <a:rPr lang="en-US" sz="1050" dirty="0">
                 <a:solidFill>
                   <a:srgbClr val="E8EAEC"/>
                 </a:solidFill>
@@ -15306,7 +15630,7 @@
               </a:rPr>
               <a:t>Machine master with ideal speeds and OEE targets, SKU catalogue, lines, defects, materials, every dropdown source</a:t>
             </a:r>
-            <a:endParaRPr lang="en-US" sz="1150" dirty="0"/>
+            <a:endParaRPr lang="en-US" sz="1050" dirty="0"/>
           </a:p>
         </p:txBody>
       </p:sp>
@@ -15358,7 +15682,7 @@
         <p:spPr>
           <a:xfrm>
             <a:off x="548640" y="2660904"/>
-            <a:ext cx="6766560" cy="786384"/>
+            <a:ext cx="6172200" cy="786384"/>
           </a:xfrm>
           <a:prstGeom prst="rect">
             <a:avLst/>
@@ -15378,7 +15702,7 @@
         <p:spPr>
           <a:xfrm>
             <a:off x="822960" y="2660904"/>
-            <a:ext cx="3108960" cy="786384"/>
+            <a:ext cx="2834640" cy="786384"/>
           </a:xfrm>
           <a:prstGeom prst="rect">
             <a:avLst/>
@@ -15416,24 +15740,24 @@
         </p:nvSpPr>
         <p:spPr>
           <a:xfrm>
-            <a:off x="3840480" y="2660904"/>
-            <a:ext cx="3291840" cy="786384"/>
-          </a:xfrm>
-          <a:prstGeom prst="rect">
-            <a:avLst/>
-          </a:prstGeom>
-          <a:noFill/>
-          <a:ln/>
-        </p:spPr>
-        <p:txBody>
-          <a:bodyPr wrap="square" lIns="0" tIns="0" rIns="0" bIns="0" rtlCol="0" anchor="ctr"/>
-          <a:lstStyle/>
-          <a:p>
-            <a:pPr indent="0" marL="0">
-              <a:buNone/>
-            </a:pPr>
-            <a:r>
-              <a:rPr lang="en-US" sz="1150" dirty="0">
+            <a:off x="3611880" y="2660904"/>
+            <a:ext cx="2971800" cy="786384"/>
+          </a:xfrm>
+          <a:prstGeom prst="rect">
+            <a:avLst/>
+          </a:prstGeom>
+          <a:noFill/>
+          <a:ln/>
+        </p:spPr>
+        <p:txBody>
+          <a:bodyPr wrap="square" lIns="0" tIns="0" rIns="0" bIns="0" rtlCol="0" anchor="ctr"/>
+          <a:lstStyle/>
+          <a:p>
+            <a:pPr indent="0" marL="0">
+              <a:buNone/>
+            </a:pPr>
+            <a:r>
+              <a:rPr lang="en-US" sz="1050" dirty="0">
                 <a:solidFill>
                   <a:srgbClr val="E8EAEC"/>
                 </a:solidFill>
@@ -15443,7 +15767,7 @@
               </a:rPr>
               <a:t>RAW Production, Handle, QC, Dispatch, Downtime, Material Requirement Slip, GRN: the only sheets users type into</a:t>
             </a:r>
-            <a:endParaRPr lang="en-US" sz="1150" dirty="0"/>
+            <a:endParaRPr lang="en-US" sz="1050" dirty="0"/>
           </a:p>
         </p:txBody>
       </p:sp>
@@ -15495,7 +15819,7 @@
         <p:spPr>
           <a:xfrm>
             <a:off x="548640" y="3630168"/>
-            <a:ext cx="6766560" cy="786384"/>
+            <a:ext cx="6172200" cy="786384"/>
           </a:xfrm>
           <a:prstGeom prst="rect">
             <a:avLst/>
@@ -15515,7 +15839,7 @@
         <p:spPr>
           <a:xfrm>
             <a:off x="822960" y="3630168"/>
-            <a:ext cx="3108960" cy="786384"/>
+            <a:ext cx="2834640" cy="786384"/>
           </a:xfrm>
           <a:prstGeom prst="rect">
             <a:avLst/>
@@ -15553,24 +15877,24 @@
         </p:nvSpPr>
         <p:spPr>
           <a:xfrm>
-            <a:off x="3840480" y="3630168"/>
-            <a:ext cx="3291840" cy="786384"/>
-          </a:xfrm>
-          <a:prstGeom prst="rect">
-            <a:avLst/>
-          </a:prstGeom>
-          <a:noFill/>
-          <a:ln/>
-        </p:spPr>
-        <p:txBody>
-          <a:bodyPr wrap="square" lIns="0" tIns="0" rIns="0" bIns="0" rtlCol="0" anchor="ctr"/>
-          <a:lstStyle/>
-          <a:p>
-            <a:pPr indent="0" marL="0">
-              <a:buNone/>
-            </a:pPr>
-            <a:r>
-              <a:rPr lang="en-US" sz="1150" dirty="0">
+            <a:off x="3611880" y="3630168"/>
+            <a:ext cx="2971800" cy="786384"/>
+          </a:xfrm>
+          <a:prstGeom prst="rect">
+            <a:avLst/>
+          </a:prstGeom>
+          <a:noFill/>
+          <a:ln/>
+        </p:spPr>
+        <p:txBody>
+          <a:bodyPr wrap="square" lIns="0" tIns="0" rIns="0" bIns="0" rtlCol="0" anchor="ctr"/>
+          <a:lstStyle/>
+          <a:p>
+            <a:pPr indent="0" marL="0">
+              <a:buNone/>
+            </a:pPr>
+            <a:r>
+              <a:rPr lang="en-US" sz="1050" dirty="0">
                 <a:solidFill>
                   <a:srgbClr val="E8EAEC"/>
                 </a:solidFill>
@@ -15580,7 +15904,7 @@
               </a:rPr>
               <a:t>OEE_Calculation and Master Traceability: one consolidated row per production run</a:t>
             </a:r>
-            <a:endParaRPr lang="en-US" sz="1150" dirty="0"/>
+            <a:endParaRPr lang="en-US" sz="1050" dirty="0"/>
           </a:p>
         </p:txBody>
       </p:sp>
@@ -15632,7 +15956,7 @@
         <p:spPr>
           <a:xfrm>
             <a:off x="548640" y="4599432"/>
-            <a:ext cx="6766560" cy="786384"/>
+            <a:ext cx="6172200" cy="786384"/>
           </a:xfrm>
           <a:prstGeom prst="rect">
             <a:avLst/>
@@ -15652,7 +15976,7 @@
         <p:spPr>
           <a:xfrm>
             <a:off x="822960" y="4599432"/>
-            <a:ext cx="3108960" cy="786384"/>
+            <a:ext cx="2834640" cy="786384"/>
           </a:xfrm>
           <a:prstGeom prst="rect">
             <a:avLst/>
@@ -15690,24 +16014,24 @@
         </p:nvSpPr>
         <p:spPr>
           <a:xfrm>
-            <a:off x="3840480" y="4599432"/>
-            <a:ext cx="3291840" cy="786384"/>
-          </a:xfrm>
-          <a:prstGeom prst="rect">
-            <a:avLst/>
-          </a:prstGeom>
-          <a:noFill/>
-          <a:ln/>
-        </p:spPr>
-        <p:txBody>
-          <a:bodyPr wrap="square" lIns="0" tIns="0" rIns="0" bIns="0" rtlCol="0" anchor="ctr"/>
-          <a:lstStyle/>
-          <a:p>
-            <a:pPr indent="0" marL="0">
-              <a:buNone/>
-            </a:pPr>
-            <a:r>
-              <a:rPr lang="en-US" sz="1150" dirty="0">
+            <a:off x="3611880" y="4599432"/>
+            <a:ext cx="2971800" cy="786384"/>
+          </a:xfrm>
+          <a:prstGeom prst="rect">
+            <a:avLst/>
+          </a:prstGeom>
+          <a:noFill/>
+          <a:ln/>
+        </p:spPr>
+        <p:txBody>
+          <a:bodyPr wrap="square" lIns="0" tIns="0" rIns="0" bIns="0" rtlCol="0" anchor="ctr"/>
+          <a:lstStyle/>
+          <a:p>
+            <a:pPr indent="0" marL="0">
+              <a:buNone/>
+            </a:pPr>
+            <a:r>
+              <a:rPr lang="en-US" sz="1050" dirty="0">
                 <a:solidFill>
                   <a:srgbClr val="E8EAEC"/>
                 </a:solidFill>
@@ -15717,7 +16041,7 @@
               </a:rPr>
               <a:t>Dashboard, OEE, Production, Quality, Downtime, Inventory, Alerts, Trace Report, Reverse Trace, Complaint Tool</a:t>
             </a:r>
-            <a:endParaRPr lang="en-US" sz="1150" dirty="0"/>
+            <a:endParaRPr lang="en-US" sz="1050" dirty="0"/>
           </a:p>
         </p:txBody>
       </p:sp>
@@ -15769,7 +16093,7 @@
         <p:spPr>
           <a:xfrm>
             <a:off x="548640" y="5568696"/>
-            <a:ext cx="6766560" cy="786384"/>
+            <a:ext cx="6172200" cy="786384"/>
           </a:xfrm>
           <a:prstGeom prst="rect">
             <a:avLst/>
@@ -15789,7 +16113,7 @@
         <p:spPr>
           <a:xfrm>
             <a:off x="822960" y="5568696"/>
-            <a:ext cx="3108960" cy="786384"/>
+            <a:ext cx="2834640" cy="786384"/>
           </a:xfrm>
           <a:prstGeom prst="rect">
             <a:avLst/>
@@ -15827,24 +16151,24 @@
         </p:nvSpPr>
         <p:spPr>
           <a:xfrm>
-            <a:off x="3840480" y="5568696"/>
-            <a:ext cx="3291840" cy="786384"/>
-          </a:xfrm>
-          <a:prstGeom prst="rect">
-            <a:avLst/>
-          </a:prstGeom>
-          <a:noFill/>
-          <a:ln/>
-        </p:spPr>
-        <p:txBody>
-          <a:bodyPr wrap="square" lIns="0" tIns="0" rIns="0" bIns="0" rtlCol="0" anchor="ctr"/>
-          <a:lstStyle/>
-          <a:p>
-            <a:pPr indent="0" marL="0">
-              <a:buNone/>
-            </a:pPr>
-            <a:r>
-              <a:rPr lang="en-US" sz="1150" dirty="0">
+            <a:off x="3611880" y="5568696"/>
+            <a:ext cx="2971800" cy="786384"/>
+          </a:xfrm>
+          <a:prstGeom prst="rect">
+            <a:avLst/>
+          </a:prstGeom>
+          <a:noFill/>
+          <a:ln/>
+        </p:spPr>
+        <p:txBody>
+          <a:bodyPr wrap="square" lIns="0" tIns="0" rIns="0" bIns="0" rtlCol="0" anchor="ctr"/>
+          <a:lstStyle/>
+          <a:p>
+            <a:pPr indent="0" marL="0">
+              <a:buNone/>
+            </a:pPr>
+            <a:r>
+              <a:rPr lang="en-US" sz="1050" dirty="0">
                 <a:solidFill>
                   <a:srgbClr val="E8EAEC"/>
                 </a:solidFill>
@@ -15854,7 +16178,7 @@
               </a:rPr>
               <a:t>Architecture, Instructions, Beginner Guide</a:t>
             </a:r>
-            <a:endParaRPr lang="en-US" sz="1150" dirty="0"/>
+            <a:endParaRPr lang="en-US" sz="1050" dirty="0"/>
           </a:p>
         </p:txBody>
       </p:sp>
@@ -15866,8 +16190,8 @@
         </p:nvSpPr>
         <p:spPr>
           <a:xfrm>
-            <a:off x="7818120" y="1737360"/>
-            <a:ext cx="3840480" cy="274320"/>
+            <a:off x="7086600" y="1737360"/>
+            <a:ext cx="4572000" cy="274320"/>
           </a:xfrm>
           <a:prstGeom prst="rect">
             <a:avLst/>
@@ -15905,8 +16229,8 @@
         </p:nvSpPr>
         <p:spPr>
           <a:xfrm>
-            <a:off x="7818120" y="2103120"/>
-            <a:ext cx="3840480" cy="2743200"/>
+            <a:off x="7086600" y="2057400"/>
+            <a:ext cx="4572000" cy="2103120"/>
           </a:xfrm>
           <a:prstGeom prst="rect">
             <a:avLst/>
@@ -15920,12 +16244,12 @@
           <a:p>
             <a:pPr indent="0" marL="0">
               <a:spcAft>
-                <a:spcPts val="800"/>
+                <a:spcPts val="500"/>
               </a:spcAft>
               <a:buNone/>
             </a:pPr>
             <a:r>
-              <a:rPr lang="en-US" sz="1300" dirty="0">
+              <a:rPr lang="en-US" sz="1200" dirty="0">
                 <a:solidFill>
                   <a:srgbClr val="3E4750"/>
                 </a:solidFill>
@@ -15935,17 +16259,17 @@
               </a:rPr>
               <a:t>Master data defines the allowed values once.</a:t>
             </a:r>
-            <a:endParaRPr lang="en-US" sz="1300" dirty="0"/>
+            <a:endParaRPr lang="en-US" sz="1200" dirty="0"/>
           </a:p>
           <a:p>
             <a:pPr indent="0" marL="0">
               <a:spcAft>
-                <a:spcPts val="800"/>
+                <a:spcPts val="500"/>
               </a:spcAft>
               <a:buNone/>
             </a:pPr>
             <a:r>
-              <a:rPr lang="en-US" sz="1300" dirty="0">
+              <a:rPr lang="en-US" sz="1200" dirty="0">
                 <a:solidFill>
                   <a:srgbClr val="3E4750"/>
                 </a:solidFill>
@@ -15955,17 +16279,17 @@
               </a:rPr>
               <a:t>Transaction registers capture each event against those values.</a:t>
             </a:r>
-            <a:endParaRPr lang="en-US" sz="1300" dirty="0"/>
+            <a:endParaRPr lang="en-US" sz="1200" dirty="0"/>
           </a:p>
           <a:p>
             <a:pPr indent="0" marL="0">
               <a:spcAft>
-                <a:spcPts val="800"/>
+                <a:spcPts val="500"/>
               </a:spcAft>
               <a:buNone/>
             </a:pPr>
             <a:r>
-              <a:rPr lang="en-US" sz="1300" dirty="0">
+              <a:rPr lang="en-US" sz="1200" dirty="0">
                 <a:solidFill>
                   <a:srgbClr val="3E4750"/>
                 </a:solidFill>
@@ -15975,17 +16299,17 @@
               </a:rPr>
               <a:t>Calculation joins and summarises the registers.</a:t>
             </a:r>
-            <a:endParaRPr lang="en-US" sz="1300" dirty="0"/>
+            <a:endParaRPr lang="en-US" sz="1200" dirty="0"/>
           </a:p>
           <a:p>
             <a:pPr indent="0" marL="0">
               <a:spcAft>
-                <a:spcPts val="800"/>
+                <a:spcPts val="500"/>
               </a:spcAft>
               <a:buNone/>
             </a:pPr>
             <a:r>
-              <a:rPr lang="en-US" sz="1300" dirty="0">
+              <a:rPr lang="en-US" sz="1200" dirty="0">
                 <a:solidFill>
                   <a:srgbClr val="3E4750"/>
                 </a:solidFill>
@@ -15995,17 +16319,17 @@
               </a:rPr>
               <a:t>Presentation answers the questions: dashboards and trace reports.</a:t>
             </a:r>
-            <a:endParaRPr lang="en-US" sz="1300" dirty="0"/>
+            <a:endParaRPr lang="en-US" sz="1200" dirty="0"/>
           </a:p>
           <a:p>
             <a:pPr indent="0" marL="0">
               <a:spcAft>
-                <a:spcPts val="800"/>
+                <a:spcPts val="500"/>
               </a:spcAft>
               <a:buNone/>
             </a:pPr>
             <a:r>
-              <a:rPr lang="en-US" sz="1300" dirty="0">
+              <a:rPr lang="en-US" sz="1200" dirty="0">
                 <a:solidFill>
                   <a:srgbClr val="3E4750"/>
                 </a:solidFill>
@@ -16015,7 +16339,7 @@
               </a:rPr>
               <a:t>Documentation explains how to use and maintain it.</a:t>
             </a:r>
-            <a:endParaRPr lang="en-US" sz="1300" dirty="0"/>
+            <a:endParaRPr lang="en-US" sz="1200" dirty="0"/>
           </a:p>
         </p:txBody>
       </p:sp>
@@ -16027,8 +16351,8 @@
         </p:nvSpPr>
         <p:spPr>
           <a:xfrm>
-            <a:off x="7818120" y="5074920"/>
-            <a:ext cx="3840480" cy="731520"/>
+            <a:off x="7086600" y="4160520"/>
+            <a:ext cx="4572000" cy="640080"/>
           </a:xfrm>
           <a:prstGeom prst="rect">
             <a:avLst/>
@@ -16044,7 +16368,7 @@
               <a:buNone/>
             </a:pPr>
             <a:r>
-              <a:rPr lang="en-US" sz="1500" i="1" dirty="0">
+              <a:rPr lang="en-US" sz="1400" i="1" dirty="0">
                 <a:solidFill>
                   <a:srgbClr val="1A1D21"/>
                 </a:solidFill>
@@ -16054,13 +16378,122 @@
               </a:rPr>
               <a:t>27 worksheets. No macros. Data flows one way, so a dashboard figure and a trace record can't disagree.</a:t>
             </a:r>
-            <a:endParaRPr lang="en-US" sz="1500" dirty="0"/>
-          </a:p>
-        </p:txBody>
-      </p:sp>
-      <p:sp>
-        <p:nvSpPr>
-          <p:cNvPr id="26" name="Text 24"/>
+            <a:endParaRPr lang="en-US" sz="1400" dirty="0"/>
+          </a:p>
+        </p:txBody>
+      </p:sp>
+      <p:sp>
+        <p:nvSpPr>
+          <p:cNvPr id="26" name="Shape 24"/>
+          <p:cNvSpPr/>
+          <p:nvPr/>
+        </p:nvSpPr>
+        <p:spPr>
+          <a:xfrm>
+            <a:off x="7040880" y="4983480"/>
+            <a:ext cx="2788920" cy="1230146"/>
+          </a:xfrm>
+          <a:prstGeom prst="rect">
+            <a:avLst/>
+          </a:prstGeom>
+          <a:solidFill>
+            <a:srgbClr val="FFFFFF"/>
+          </a:solidFill>
+          <a:ln w="9525">
+            <a:solidFill>
+              <a:srgbClr val="D6D8D6"/>
+            </a:solidFill>
+            <a:prstDash val="solid"/>
+          </a:ln>
+          <a:effectLst>
+            <a:outerShdw sx="100000" sy="100000" kx="0" ky="0" algn="bl" rotWithShape="0" blurRad="101600" dist="25400" dir="5400000">
+              <a:srgbClr val="000000">
+                <a:alpha val="18000"/>
+              </a:srgbClr>
+            </a:outerShdw>
+          </a:effectLst>
+        </p:spPr>
+      </p:sp>
+      <p:pic>
+        <p:nvPicPr>
+          <p:cNvPr id="27" name="Image 0" descr="/home/user/master-executive-system/sip-presentation/source/records/rec_traceability_p1_c.jpg">    </p:cNvPr>
+          <p:cNvPicPr>
+            <a:picLocks noChangeAspect="1"/>
+          </p:cNvPicPr>
+          <p:nvPr/>
+        </p:nvPicPr>
+        <p:blipFill>
+          <a:blip r:embed="rId1"/>
+          <a:stretch>
+            <a:fillRect/>
+          </a:stretch>
+        </p:blipFill>
+        <p:spPr>
+          <a:xfrm>
+            <a:off x="7086600" y="5029200"/>
+            <a:ext cx="2697480" cy="1138706"/>
+          </a:xfrm>
+          <a:prstGeom prst="rect">
+            <a:avLst/>
+          </a:prstGeom>
+        </p:spPr>
+      </p:pic>
+      <p:sp>
+        <p:nvSpPr>
+          <p:cNvPr id="28" name="Text 25"/>
+          <p:cNvSpPr txBox="1"/>
+          <p:nvPr/>
+        </p:nvSpPr>
+        <p:spPr>
+          <a:xfrm>
+            <a:off x="9966960" y="4983480"/>
+            <a:ext cx="1691640" cy="1417320"/>
+          </a:xfrm>
+          <a:prstGeom prst="rect">
+            <a:avLst/>
+          </a:prstGeom>
+          <a:noFill/>
+          <a:ln/>
+        </p:spPr>
+        <p:txBody>
+          <a:bodyPr wrap="square" lIns="0" tIns="0" rIns="0" bIns="0" rtlCol="0" anchor="t"/>
+          <a:lstStyle/>
+          <a:p>
+            <a:pPr indent="0" marL="0">
+              <a:buNone/>
+            </a:pPr>
+            <a:r>
+              <a:rPr lang="en-US" sz="950" b="1" dirty="0">
+                <a:solidFill>
+                  <a:srgbClr val="1A1D21"/>
+                </a:solidFill>
+                <a:latin typeface="Calibri" pitchFamily="34" charset="0"/>
+                <a:ea typeface="Calibri" pitchFamily="34" charset="-122"/>
+                <a:cs typeface="Calibri" pitchFamily="34" charset="-120"/>
+              </a:rPr>
+              <a:t>Before: </a:t>
+            </a:r>
+            <a:pPr indent="0" marL="0">
+              <a:buNone/>
+            </a:pPr>
+            <a:r>
+              <a:rPr lang="en-US" sz="950" dirty="0">
+                <a:solidFill>
+                  <a:srgbClr val="3E4750"/>
+                </a:solidFill>
+                <a:latin typeface="Calibri" pitchFamily="34" charset="0"/>
+                <a:ea typeface="Calibri" pitchFamily="34" charset="-122"/>
+                <a:cs typeface="Calibri" pitchFamily="34" charset="-120"/>
+              </a:rPr>
+              <a:t>the plant's paper traceability report for the same brush line. Its columns became register fields: handle lot, nylon and brass-wire lots, packing materials, machines.</a:t>
+            </a:r>
+            <a:endParaRPr lang="en-US" sz="950" dirty="0"/>
+          </a:p>
+        </p:txBody>
+      </p:sp>
+      <p:sp>
+        <p:nvSpPr>
+          <p:cNvPr id="29" name="Text 26"/>
           <p:cNvSpPr txBox="1"/>
           <p:nvPr/>
         </p:nvSpPr>
@@ -29208,117 +29641,158 @@
           </a:p>
         </p:txBody>
       </p:sp>
-      <p:pic>
-        <p:nvPicPr>
-          <p:cNvPr id="4" name="Image 0" descr="/home/user/master-executive-system/sip-presentation/source/photos/4.jpg">    </p:cNvPr>
-          <p:cNvPicPr>
-            <a:picLocks noChangeAspect="1"/>
-          </p:cNvPicPr>
-          <p:nvPr/>
-        </p:nvPicPr>
-        <p:blipFill>
-          <a:blip r:embed="rId1"/>
-          <a:srcRect l="0" r="0" t="0" b="0"/>
-          <a:stretch/>
-        </p:blipFill>
-        <p:spPr>
-          <a:xfrm>
-            <a:off x="548640" y="1463040"/>
-            <a:ext cx="3520440" cy="1554480"/>
-          </a:xfrm>
-          <a:prstGeom prst="rect">
-            <a:avLst/>
-          </a:prstGeom>
-        </p:spPr>
-      </p:pic>
-      <p:sp>
-        <p:nvSpPr>
-          <p:cNvPr id="5" name="Text 2"/>
-          <p:cNvSpPr txBox="1"/>
-          <p:nvPr/>
-        </p:nvSpPr>
-        <p:spPr>
-          <a:xfrm>
-            <a:off x="548640" y="3200400"/>
-            <a:ext cx="3520440" cy="274320"/>
-          </a:xfrm>
-          <a:prstGeom prst="rect">
-            <a:avLst/>
-          </a:prstGeom>
-          <a:noFill/>
-          <a:ln/>
-        </p:spPr>
-        <p:txBody>
-          <a:bodyPr wrap="square" lIns="0" tIns="0" rIns="0" bIns="0" rtlCol="0" anchor="ctr"/>
-          <a:lstStyle/>
-          <a:p>
-            <a:pPr indent="0" marL="0">
-              <a:buNone/>
-            </a:pPr>
-            <a:r>
-              <a:rPr lang="en-US" sz="1100" b="1" spc="300" kern="0" dirty="0">
+      <p:sp>
+        <p:nvSpPr>
+          <p:cNvPr id="4" name="Shape 2"/>
+          <p:cNvSpPr/>
+          <p:nvPr/>
+        </p:nvSpPr>
+        <p:spPr>
+          <a:xfrm>
+            <a:off x="548640" y="1600200"/>
+            <a:ext cx="3520440" cy="4343400"/>
+          </a:xfrm>
+          <a:prstGeom prst="rect">
+            <a:avLst/>
+          </a:prstGeom>
+          <a:solidFill>
+            <a:srgbClr val="F4F4F1"/>
+          </a:solidFill>
+          <a:ln w="9525">
+            <a:solidFill>
+              <a:srgbClr val="D6D8D6"/>
+            </a:solidFill>
+            <a:prstDash val="solid"/>
+          </a:ln>
+        </p:spPr>
+      </p:sp>
+      <p:sp>
+        <p:nvSpPr>
+          <p:cNvPr id="5" name="Text 3"/>
+          <p:cNvSpPr txBox="1"/>
+          <p:nvPr/>
+        </p:nvSpPr>
+        <p:spPr>
+          <a:xfrm>
+            <a:off x="822960" y="1783080"/>
+            <a:ext cx="1371600" cy="822960"/>
+          </a:xfrm>
+          <a:prstGeom prst="rect">
+            <a:avLst/>
+          </a:prstGeom>
+          <a:noFill/>
+          <a:ln/>
+        </p:spPr>
+        <p:txBody>
+          <a:bodyPr wrap="square" lIns="0" tIns="0" rIns="0" bIns="0" rtlCol="0" anchor="t"/>
+          <a:lstStyle/>
+          <a:p>
+            <a:pPr indent="0" marL="0">
+              <a:buNone/>
+            </a:pPr>
+            <a:r>
+              <a:rPr lang="en-US" sz="4800" dirty="0">
                 <a:solidFill>
                   <a:srgbClr val="E0561F"/>
-                </a:solidFill>
-                <a:latin typeface="Calibri" pitchFamily="34" charset="0"/>
-                <a:ea typeface="Calibri" pitchFamily="34" charset="-122"/>
-                <a:cs typeface="Calibri" pitchFamily="34" charset="-120"/>
-              </a:rPr>
-              <a:t>THE PLANT</a:t>
-            </a:r>
-            <a:endParaRPr lang="en-US" sz="1100" dirty="0"/>
-          </a:p>
-        </p:txBody>
-      </p:sp>
-      <p:sp>
-        <p:nvSpPr>
-          <p:cNvPr id="6" name="Text 3"/>
-          <p:cNvSpPr txBox="1"/>
-          <p:nvPr/>
-        </p:nvSpPr>
-        <p:spPr>
-          <a:xfrm>
-            <a:off x="548640" y="3493008"/>
-            <a:ext cx="3520440" cy="411480"/>
-          </a:xfrm>
-          <a:prstGeom prst="rect">
-            <a:avLst/>
-          </a:prstGeom>
-          <a:noFill/>
-          <a:ln/>
-        </p:spPr>
-        <p:txBody>
-          <a:bodyPr wrap="square" lIns="0" tIns="0" rIns="0" bIns="0" rtlCol="0" anchor="ctr"/>
-          <a:lstStyle/>
-          <a:p>
-            <a:pPr indent="0" marL="0">
-              <a:buNone/>
-            </a:pPr>
-            <a:r>
-              <a:rPr lang="en-US" sz="1900" dirty="0">
-                <a:solidFill>
-                  <a:srgbClr val="1A1D21"/>
                 </a:solidFill>
                 <a:latin typeface="Cambria" pitchFamily="34" charset="0"/>
                 <a:ea typeface="Cambria" pitchFamily="34" charset="-122"/>
                 <a:cs typeface="Cambria" pitchFamily="34" charset="-120"/>
               </a:rPr>
+              <a:t>01</a:t>
+            </a:r>
+            <a:endParaRPr lang="en-US" sz="4800" dirty="0"/>
+          </a:p>
+        </p:txBody>
+      </p:sp>
+      <p:sp>
+        <p:nvSpPr>
+          <p:cNvPr id="6" name="Text 4"/>
+          <p:cNvSpPr txBox="1"/>
+          <p:nvPr/>
+        </p:nvSpPr>
+        <p:spPr>
+          <a:xfrm>
+            <a:off x="822960" y="2788920"/>
+            <a:ext cx="2971800" cy="274320"/>
+          </a:xfrm>
+          <a:prstGeom prst="rect">
+            <a:avLst/>
+          </a:prstGeom>
+          <a:noFill/>
+          <a:ln/>
+        </p:spPr>
+        <p:txBody>
+          <a:bodyPr wrap="square" lIns="0" tIns="0" rIns="0" bIns="0" rtlCol="0" anchor="ctr"/>
+          <a:lstStyle/>
+          <a:p>
+            <a:pPr indent="0" marL="0">
+              <a:buNone/>
+            </a:pPr>
+            <a:r>
+              <a:rPr lang="en-US" sz="1100" b="1" spc="300" kern="0" dirty="0">
+                <a:solidFill>
+                  <a:srgbClr val="E0561F"/>
+                </a:solidFill>
+                <a:latin typeface="Calibri" pitchFamily="34" charset="0"/>
+                <a:ea typeface="Calibri" pitchFamily="34" charset="-122"/>
+                <a:cs typeface="Calibri" pitchFamily="34" charset="-120"/>
+              </a:rPr>
+              <a:t>THE PLANT</a:t>
+            </a:r>
+            <a:endParaRPr lang="en-US" sz="1100" dirty="0"/>
+          </a:p>
+        </p:txBody>
+      </p:sp>
+      <p:sp>
+        <p:nvSpPr>
+          <p:cNvPr id="7" name="Text 5"/>
+          <p:cNvSpPr txBox="1"/>
+          <p:nvPr/>
+        </p:nvSpPr>
+        <p:spPr>
+          <a:xfrm>
+            <a:off x="822960" y="3081528"/>
+            <a:ext cx="2971800" cy="411480"/>
+          </a:xfrm>
+          <a:prstGeom prst="rect">
+            <a:avLst/>
+          </a:prstGeom>
+          <a:noFill/>
+          <a:ln/>
+        </p:spPr>
+        <p:txBody>
+          <a:bodyPr wrap="square" lIns="0" tIns="0" rIns="0" bIns="0" rtlCol="0" anchor="ctr"/>
+          <a:lstStyle/>
+          <a:p>
+            <a:pPr indent="0" marL="0">
+              <a:buNone/>
+            </a:pPr>
+            <a:r>
+              <a:rPr lang="en-US" sz="1700" dirty="0">
+                <a:solidFill>
+                  <a:srgbClr val="1A1D21"/>
+                </a:solidFill>
+                <a:latin typeface="Cambria" pitchFamily="34" charset="0"/>
+                <a:ea typeface="Cambria" pitchFamily="34" charset="-122"/>
+                <a:cs typeface="Cambria" pitchFamily="34" charset="-120"/>
+              </a:rPr>
               <a:t>Manufacturing understanding</a:t>
             </a:r>
-            <a:endParaRPr lang="en-US" sz="1900" dirty="0"/>
-          </a:p>
-        </p:txBody>
-      </p:sp>
-      <p:sp>
-        <p:nvSpPr>
-          <p:cNvPr id="7" name="Text 4"/>
-          <p:cNvSpPr txBox="1"/>
-          <p:nvPr/>
-        </p:nvSpPr>
-        <p:spPr>
-          <a:xfrm>
-            <a:off x="548640" y="4023360"/>
-            <a:ext cx="3520440" cy="2286000"/>
+            <a:endParaRPr lang="en-US" sz="1700" dirty="0"/>
+          </a:p>
+        </p:txBody>
+      </p:sp>
+      <p:sp>
+        <p:nvSpPr>
+          <p:cNvPr id="8" name="Text 6"/>
+          <p:cNvSpPr txBox="1"/>
+          <p:nvPr/>
+        </p:nvSpPr>
+        <p:spPr>
+          <a:xfrm>
+            <a:off x="822960" y="3703320"/>
+            <a:ext cx="2971800" cy="2103120"/>
           </a:xfrm>
           <a:prstGeom prst="rect">
             <a:avLst/>
@@ -29332,13 +29806,13 @@
           <a:p>
             <a:pPr marL="342900" indent="-342900">
               <a:spcAft>
-                <a:spcPts val="600"/>
+                <a:spcPts val="1000"/>
               </a:spcAft>
               <a:buSzPct val="100000"/>
               <a:buChar char="•"/>
             </a:pPr>
             <a:r>
-              <a:rPr lang="en-US" sz="1300" dirty="0">
+              <a:rPr lang="en-US" sz="1400" dirty="0">
                 <a:solidFill>
                   <a:srgbClr val="3E4750"/>
                 </a:solidFill>
@@ -29348,18 +29822,18 @@
               </a:rPr>
               <a:t>How material, people and machines actually move</a:t>
             </a:r>
-            <a:endParaRPr lang="en-US" sz="1300" dirty="0"/>
+            <a:endParaRPr lang="en-US" sz="1400" dirty="0"/>
           </a:p>
           <a:p>
             <a:pPr marL="342900" indent="-342900">
               <a:spcAft>
-                <a:spcPts val="600"/>
+                <a:spcPts val="1000"/>
               </a:spcAft>
               <a:buSzPct val="100000"/>
               <a:buChar char="•"/>
             </a:pPr>
             <a:r>
-              <a:rPr lang="en-US" sz="1300" dirty="0">
+              <a:rPr lang="en-US" sz="1400" dirty="0">
                 <a:solidFill>
                   <a:srgbClr val="3E4750"/>
                 </a:solidFill>
@@ -29369,18 +29843,18 @@
               </a:rPr>
               <a:t>Where records are created, and why</a:t>
             </a:r>
-            <a:endParaRPr lang="en-US" sz="1300" dirty="0"/>
+            <a:endParaRPr lang="en-US" sz="1400" dirty="0"/>
           </a:p>
           <a:p>
             <a:pPr marL="342900" indent="-342900">
               <a:spcAft>
-                <a:spcPts val="600"/>
+                <a:spcPts val="1000"/>
               </a:spcAft>
               <a:buSzPct val="100000"/>
               <a:buChar char="•"/>
             </a:pPr>
             <a:r>
-              <a:rPr lang="en-US" sz="1300" dirty="0">
+              <a:rPr lang="en-US" sz="1400" dirty="0">
                 <a:solidFill>
                   <a:srgbClr val="3E4750"/>
                 </a:solidFill>
@@ -29390,18 +29864,18 @@
               </a:rPr>
               <a:t>Traceability as a quality obligation</a:t>
             </a:r>
-            <a:endParaRPr lang="en-US" sz="1300" dirty="0"/>
+            <a:endParaRPr lang="en-US" sz="1400" dirty="0"/>
           </a:p>
           <a:p>
             <a:pPr marL="342900" indent="-342900">
               <a:spcAft>
-                <a:spcPts val="600"/>
+                <a:spcPts val="1000"/>
               </a:spcAft>
               <a:buSzPct val="100000"/>
               <a:buChar char="•"/>
             </a:pPr>
             <a:r>
-              <a:rPr lang="en-US" sz="1300" dirty="0">
+              <a:rPr lang="en-US" sz="1400" dirty="0">
                 <a:solidFill>
                   <a:srgbClr val="3E4750"/>
                 </a:solidFill>
@@ -29411,121 +29885,162 @@
               </a:rPr>
               <a:t>OEE and where time really goes</a:t>
             </a:r>
-            <a:endParaRPr lang="en-US" sz="1300" dirty="0"/>
-          </a:p>
-        </p:txBody>
-      </p:sp>
-      <p:pic>
-        <p:nvPicPr>
-          <p:cNvPr id="8" name="Image 1" descr="/home/user/master-executive-system/sip-presentation/source/crops/dash_top.png">    </p:cNvPr>
-          <p:cNvPicPr>
-            <a:picLocks noChangeAspect="1"/>
-          </p:cNvPicPr>
-          <p:nvPr/>
-        </p:nvPicPr>
-        <p:blipFill>
-          <a:blip r:embed="rId2"/>
-          <a:srcRect l="0" r="0" t="0" b="0"/>
-          <a:stretch/>
-        </p:blipFill>
-        <p:spPr>
-          <a:xfrm>
-            <a:off x="4343400" y="1463040"/>
-            <a:ext cx="3520440" cy="1554480"/>
-          </a:xfrm>
-          <a:prstGeom prst="rect">
-            <a:avLst/>
-          </a:prstGeom>
-        </p:spPr>
-      </p:pic>
-      <p:sp>
-        <p:nvSpPr>
-          <p:cNvPr id="9" name="Text 5"/>
-          <p:cNvSpPr txBox="1"/>
-          <p:nvPr/>
-        </p:nvSpPr>
-        <p:spPr>
-          <a:xfrm>
-            <a:off x="4343400" y="3200400"/>
-            <a:ext cx="3520440" cy="274320"/>
-          </a:xfrm>
-          <a:prstGeom prst="rect">
-            <a:avLst/>
-          </a:prstGeom>
-          <a:noFill/>
-          <a:ln/>
-        </p:spPr>
-        <p:txBody>
-          <a:bodyPr wrap="square" lIns="0" tIns="0" rIns="0" bIns="0" rtlCol="0" anchor="ctr"/>
-          <a:lstStyle/>
-          <a:p>
-            <a:pPr indent="0" marL="0">
-              <a:buNone/>
-            </a:pPr>
-            <a:r>
-              <a:rPr lang="en-US" sz="1100" b="1" spc="300" kern="0" dirty="0">
-                <a:solidFill>
-                  <a:srgbClr val="E0561F"/>
-                </a:solidFill>
-                <a:latin typeface="Calibri" pitchFamily="34" charset="0"/>
-                <a:ea typeface="Calibri" pitchFamily="34" charset="-122"/>
-                <a:cs typeface="Calibri" pitchFamily="34" charset="-120"/>
-              </a:rPr>
-              <a:t>THE SYSTEM</a:t>
-            </a:r>
-            <a:endParaRPr lang="en-US" sz="1100" dirty="0"/>
-          </a:p>
-        </p:txBody>
-      </p:sp>
-      <p:sp>
-        <p:nvSpPr>
-          <p:cNvPr id="10" name="Text 6"/>
-          <p:cNvSpPr txBox="1"/>
-          <p:nvPr/>
-        </p:nvSpPr>
-        <p:spPr>
-          <a:xfrm>
-            <a:off x="4343400" y="3493008"/>
-            <a:ext cx="3520440" cy="411480"/>
-          </a:xfrm>
-          <a:prstGeom prst="rect">
-            <a:avLst/>
-          </a:prstGeom>
-          <a:noFill/>
-          <a:ln/>
-        </p:spPr>
-        <p:txBody>
-          <a:bodyPr wrap="square" lIns="0" tIns="0" rIns="0" bIns="0" rtlCol="0" anchor="ctr"/>
-          <a:lstStyle/>
-          <a:p>
-            <a:pPr indent="0" marL="0">
-              <a:buNone/>
-            </a:pPr>
-            <a:r>
-              <a:rPr lang="en-US" sz="1900" dirty="0">
-                <a:solidFill>
-                  <a:srgbClr val="1A1D21"/>
+            <a:endParaRPr lang="en-US" sz="1400" dirty="0"/>
+          </a:p>
+        </p:txBody>
+      </p:sp>
+      <p:sp>
+        <p:nvSpPr>
+          <p:cNvPr id="9" name="Shape 7"/>
+          <p:cNvSpPr/>
+          <p:nvPr/>
+        </p:nvSpPr>
+        <p:spPr>
+          <a:xfrm>
+            <a:off x="4343400" y="1600200"/>
+            <a:ext cx="3520440" cy="4343400"/>
+          </a:xfrm>
+          <a:prstGeom prst="rect">
+            <a:avLst/>
+          </a:prstGeom>
+          <a:solidFill>
+            <a:srgbClr val="FFFFFF"/>
+          </a:solidFill>
+          <a:ln w="9525">
+            <a:solidFill>
+              <a:srgbClr val="D6D8D6"/>
+            </a:solidFill>
+            <a:prstDash val="solid"/>
+          </a:ln>
+        </p:spPr>
+      </p:sp>
+      <p:sp>
+        <p:nvSpPr>
+          <p:cNvPr id="10" name="Text 8"/>
+          <p:cNvSpPr txBox="1"/>
+          <p:nvPr/>
+        </p:nvSpPr>
+        <p:spPr>
+          <a:xfrm>
+            <a:off x="4617720" y="1783080"/>
+            <a:ext cx="1371600" cy="822960"/>
+          </a:xfrm>
+          <a:prstGeom prst="rect">
+            <a:avLst/>
+          </a:prstGeom>
+          <a:noFill/>
+          <a:ln/>
+        </p:spPr>
+        <p:txBody>
+          <a:bodyPr wrap="square" lIns="0" tIns="0" rIns="0" bIns="0" rtlCol="0" anchor="t"/>
+          <a:lstStyle/>
+          <a:p>
+            <a:pPr indent="0" marL="0">
+              <a:buNone/>
+            </a:pPr>
+            <a:r>
+              <a:rPr lang="en-US" sz="4800" dirty="0">
+                <a:solidFill>
+                  <a:srgbClr val="B9BEC2"/>
                 </a:solidFill>
                 <a:latin typeface="Cambria" pitchFamily="34" charset="0"/>
                 <a:ea typeface="Cambria" pitchFamily="34" charset="-122"/>
                 <a:cs typeface="Cambria" pitchFamily="34" charset="-120"/>
               </a:rPr>
+              <a:t>02</a:t>
+            </a:r>
+            <a:endParaRPr lang="en-US" sz="4800" dirty="0"/>
+          </a:p>
+        </p:txBody>
+      </p:sp>
+      <p:sp>
+        <p:nvSpPr>
+          <p:cNvPr id="11" name="Text 9"/>
+          <p:cNvSpPr txBox="1"/>
+          <p:nvPr/>
+        </p:nvSpPr>
+        <p:spPr>
+          <a:xfrm>
+            <a:off x="4617720" y="2788920"/>
+            <a:ext cx="2971800" cy="274320"/>
+          </a:xfrm>
+          <a:prstGeom prst="rect">
+            <a:avLst/>
+          </a:prstGeom>
+          <a:noFill/>
+          <a:ln/>
+        </p:spPr>
+        <p:txBody>
+          <a:bodyPr wrap="square" lIns="0" tIns="0" rIns="0" bIns="0" rtlCol="0" anchor="ctr"/>
+          <a:lstStyle/>
+          <a:p>
+            <a:pPr indent="0" marL="0">
+              <a:buNone/>
+            </a:pPr>
+            <a:r>
+              <a:rPr lang="en-US" sz="1100" b="1" spc="300" kern="0" dirty="0">
+                <a:solidFill>
+                  <a:srgbClr val="E0561F"/>
+                </a:solidFill>
+                <a:latin typeface="Calibri" pitchFamily="34" charset="0"/>
+                <a:ea typeface="Calibri" pitchFamily="34" charset="-122"/>
+                <a:cs typeface="Calibri" pitchFamily="34" charset="-120"/>
+              </a:rPr>
+              <a:t>THE SYSTEM</a:t>
+            </a:r>
+            <a:endParaRPr lang="en-US" sz="1100" dirty="0"/>
+          </a:p>
+        </p:txBody>
+      </p:sp>
+      <p:sp>
+        <p:nvSpPr>
+          <p:cNvPr id="12" name="Text 10"/>
+          <p:cNvSpPr txBox="1"/>
+          <p:nvPr/>
+        </p:nvSpPr>
+        <p:spPr>
+          <a:xfrm>
+            <a:off x="4617720" y="3081528"/>
+            <a:ext cx="2971800" cy="411480"/>
+          </a:xfrm>
+          <a:prstGeom prst="rect">
+            <a:avLst/>
+          </a:prstGeom>
+          <a:noFill/>
+          <a:ln/>
+        </p:spPr>
+        <p:txBody>
+          <a:bodyPr wrap="square" lIns="0" tIns="0" rIns="0" bIns="0" rtlCol="0" anchor="ctr"/>
+          <a:lstStyle/>
+          <a:p>
+            <a:pPr indent="0" marL="0">
+              <a:buNone/>
+            </a:pPr>
+            <a:r>
+              <a:rPr lang="en-US" sz="1700" dirty="0">
+                <a:solidFill>
+                  <a:srgbClr val="1A1D21"/>
+                </a:solidFill>
+                <a:latin typeface="Cambria" pitchFamily="34" charset="0"/>
+                <a:ea typeface="Cambria" pitchFamily="34" charset="-122"/>
+                <a:cs typeface="Cambria" pitchFamily="34" charset="-120"/>
+              </a:rPr>
               <a:t>Technical understanding</a:t>
             </a:r>
-            <a:endParaRPr lang="en-US" sz="1900" dirty="0"/>
-          </a:p>
-        </p:txBody>
-      </p:sp>
-      <p:sp>
-        <p:nvSpPr>
-          <p:cNvPr id="11" name="Text 7"/>
-          <p:cNvSpPr txBox="1"/>
-          <p:nvPr/>
-        </p:nvSpPr>
-        <p:spPr>
-          <a:xfrm>
-            <a:off x="4343400" y="4023360"/>
-            <a:ext cx="3520440" cy="2286000"/>
+            <a:endParaRPr lang="en-US" sz="1700" dirty="0"/>
+          </a:p>
+        </p:txBody>
+      </p:sp>
+      <p:sp>
+        <p:nvSpPr>
+          <p:cNvPr id="13" name="Text 11"/>
+          <p:cNvSpPr txBox="1"/>
+          <p:nvPr/>
+        </p:nvSpPr>
+        <p:spPr>
+          <a:xfrm>
+            <a:off x="4617720" y="3703320"/>
+            <a:ext cx="2971800" cy="2103120"/>
           </a:xfrm>
           <a:prstGeom prst="rect">
             <a:avLst/>
@@ -29539,13 +30054,13 @@
           <a:p>
             <a:pPr marL="342900" indent="-342900">
               <a:spcAft>
-                <a:spcPts val="600"/>
+                <a:spcPts val="1000"/>
               </a:spcAft>
               <a:buSzPct val="100000"/>
               <a:buChar char="•"/>
             </a:pPr>
             <a:r>
-              <a:rPr lang="en-US" sz="1300" dirty="0">
+              <a:rPr lang="en-US" sz="1400" dirty="0">
                 <a:solidFill>
                   <a:srgbClr val="3E4750"/>
                 </a:solidFill>
@@ -29555,18 +30070,18 @@
               </a:rPr>
               <a:t>Data modelling: masters vs. transactions</a:t>
             </a:r>
-            <a:endParaRPr lang="en-US" sz="1300" dirty="0"/>
+            <a:endParaRPr lang="en-US" sz="1400" dirty="0"/>
           </a:p>
           <a:p>
             <a:pPr marL="342900" indent="-342900">
               <a:spcAft>
-                <a:spcPts val="600"/>
+                <a:spcPts val="1000"/>
               </a:spcAft>
               <a:buSzPct val="100000"/>
               <a:buChar char="•"/>
             </a:pPr>
             <a:r>
-              <a:rPr lang="en-US" sz="1300" dirty="0">
+              <a:rPr lang="en-US" sz="1400" dirty="0">
                 <a:solidFill>
                   <a:srgbClr val="3E4750"/>
                 </a:solidFill>
@@ -29576,18 +30091,18 @@
               </a:rPr>
               <a:t>Why a system key must be unique</a:t>
             </a:r>
-            <a:endParaRPr lang="en-US" sz="1300" dirty="0"/>
+            <a:endParaRPr lang="en-US" sz="1400" dirty="0"/>
           </a:p>
           <a:p>
             <a:pPr marL="342900" indent="-342900">
               <a:spcAft>
-                <a:spcPts val="600"/>
+                <a:spcPts val="1000"/>
               </a:spcAft>
               <a:buSzPct val="100000"/>
               <a:buChar char="•"/>
             </a:pPr>
             <a:r>
-              <a:rPr lang="en-US" sz="1300" dirty="0">
+              <a:rPr lang="en-US" sz="1400" dirty="0">
                 <a:solidFill>
                   <a:srgbClr val="3E4750"/>
                 </a:solidFill>
@@ -29597,18 +30112,18 @@
               </a:rPr>
               <a:t>Validation before calculation</a:t>
             </a:r>
-            <a:endParaRPr lang="en-US" sz="1300" dirty="0"/>
+            <a:endParaRPr lang="en-US" sz="1400" dirty="0"/>
           </a:p>
           <a:p>
             <a:pPr marL="342900" indent="-342900">
               <a:spcAft>
-                <a:spcPts val="600"/>
+                <a:spcPts val="1000"/>
               </a:spcAft>
               <a:buSzPct val="100000"/>
               <a:buChar char="•"/>
             </a:pPr>
             <a:r>
-              <a:rPr lang="en-US" sz="1300" dirty="0">
+              <a:rPr lang="en-US" sz="1400" dirty="0">
                 <a:solidFill>
                   <a:srgbClr val="3E4750"/>
                 </a:solidFill>
@@ -29618,121 +30133,162 @@
               </a:rPr>
               <a:t>Testing with real scenarios</a:t>
             </a:r>
-            <a:endParaRPr lang="en-US" sz="1300" dirty="0"/>
-          </a:p>
-        </p:txBody>
-      </p:sp>
-      <p:pic>
-        <p:nvPicPr>
-          <p:cNvPr id="12" name="Image 2" descr="/home/user/master-executive-system/sip-presentation/source/photos/3.jpg">    </p:cNvPr>
-          <p:cNvPicPr>
-            <a:picLocks noChangeAspect="1"/>
-          </p:cNvPicPr>
-          <p:nvPr/>
-        </p:nvPicPr>
-        <p:blipFill>
-          <a:blip r:embed="rId3"/>
-          <a:srcRect l="0" r="0" t="0" b="0"/>
-          <a:stretch/>
-        </p:blipFill>
-        <p:spPr>
-          <a:xfrm>
-            <a:off x="8138160" y="1463040"/>
-            <a:ext cx="3520440" cy="1554480"/>
-          </a:xfrm>
-          <a:prstGeom prst="rect">
-            <a:avLst/>
-          </a:prstGeom>
-        </p:spPr>
-      </p:pic>
-      <p:sp>
-        <p:nvSpPr>
-          <p:cNvPr id="13" name="Text 8"/>
-          <p:cNvSpPr txBox="1"/>
-          <p:nvPr/>
-        </p:nvSpPr>
-        <p:spPr>
-          <a:xfrm>
-            <a:off x="8138160" y="3200400"/>
-            <a:ext cx="3520440" cy="274320"/>
-          </a:xfrm>
-          <a:prstGeom prst="rect">
-            <a:avLst/>
-          </a:prstGeom>
-          <a:noFill/>
-          <a:ln/>
-        </p:spPr>
-        <p:txBody>
-          <a:bodyPr wrap="square" lIns="0" tIns="0" rIns="0" bIns="0" rtlCol="0" anchor="ctr"/>
-          <a:lstStyle/>
-          <a:p>
-            <a:pPr indent="0" marL="0">
-              <a:buNone/>
-            </a:pPr>
-            <a:r>
-              <a:rPr lang="en-US" sz="1100" b="1" spc="300" kern="0" dirty="0">
-                <a:solidFill>
-                  <a:srgbClr val="E0561F"/>
-                </a:solidFill>
-                <a:latin typeface="Calibri" pitchFamily="34" charset="0"/>
-                <a:ea typeface="Calibri" pitchFamily="34" charset="-122"/>
-                <a:cs typeface="Calibri" pitchFamily="34" charset="-120"/>
-              </a:rPr>
-              <a:t>THE MANAGER</a:t>
-            </a:r>
-            <a:endParaRPr lang="en-US" sz="1100" dirty="0"/>
-          </a:p>
-        </p:txBody>
-      </p:sp>
-      <p:sp>
-        <p:nvSpPr>
-          <p:cNvPr id="14" name="Text 9"/>
-          <p:cNvSpPr txBox="1"/>
-          <p:nvPr/>
-        </p:nvSpPr>
-        <p:spPr>
-          <a:xfrm>
-            <a:off x="8138160" y="3493008"/>
-            <a:ext cx="3520440" cy="411480"/>
-          </a:xfrm>
-          <a:prstGeom prst="rect">
-            <a:avLst/>
-          </a:prstGeom>
-          <a:noFill/>
-          <a:ln/>
-        </p:spPr>
-        <p:txBody>
-          <a:bodyPr wrap="square" lIns="0" tIns="0" rIns="0" bIns="0" rtlCol="0" anchor="ctr"/>
-          <a:lstStyle/>
-          <a:p>
-            <a:pPr indent="0" marL="0">
-              <a:buNone/>
-            </a:pPr>
-            <a:r>
-              <a:rPr lang="en-US" sz="1900" dirty="0">
-                <a:solidFill>
-                  <a:srgbClr val="1A1D21"/>
+            <a:endParaRPr lang="en-US" sz="1400" dirty="0"/>
+          </a:p>
+        </p:txBody>
+      </p:sp>
+      <p:sp>
+        <p:nvSpPr>
+          <p:cNvPr id="14" name="Shape 12"/>
+          <p:cNvSpPr/>
+          <p:nvPr/>
+        </p:nvSpPr>
+        <p:spPr>
+          <a:xfrm>
+            <a:off x="8138160" y="1600200"/>
+            <a:ext cx="3520440" cy="4343400"/>
+          </a:xfrm>
+          <a:prstGeom prst="rect">
+            <a:avLst/>
+          </a:prstGeom>
+          <a:solidFill>
+            <a:srgbClr val="FFFFFF"/>
+          </a:solidFill>
+          <a:ln w="9525">
+            <a:solidFill>
+              <a:srgbClr val="D6D8D6"/>
+            </a:solidFill>
+            <a:prstDash val="solid"/>
+          </a:ln>
+        </p:spPr>
+      </p:sp>
+      <p:sp>
+        <p:nvSpPr>
+          <p:cNvPr id="15" name="Text 13"/>
+          <p:cNvSpPr txBox="1"/>
+          <p:nvPr/>
+        </p:nvSpPr>
+        <p:spPr>
+          <a:xfrm>
+            <a:off x="8412480" y="1783080"/>
+            <a:ext cx="1371600" cy="822960"/>
+          </a:xfrm>
+          <a:prstGeom prst="rect">
+            <a:avLst/>
+          </a:prstGeom>
+          <a:noFill/>
+          <a:ln/>
+        </p:spPr>
+        <p:txBody>
+          <a:bodyPr wrap="square" lIns="0" tIns="0" rIns="0" bIns="0" rtlCol="0" anchor="t"/>
+          <a:lstStyle/>
+          <a:p>
+            <a:pPr indent="0" marL="0">
+              <a:buNone/>
+            </a:pPr>
+            <a:r>
+              <a:rPr lang="en-US" sz="4800" dirty="0">
+                <a:solidFill>
+                  <a:srgbClr val="B9BEC2"/>
                 </a:solidFill>
                 <a:latin typeface="Cambria" pitchFamily="34" charset="0"/>
                 <a:ea typeface="Cambria" pitchFamily="34" charset="-122"/>
                 <a:cs typeface="Cambria" pitchFamily="34" charset="-120"/>
               </a:rPr>
+              <a:t>03</a:t>
+            </a:r>
+            <a:endParaRPr lang="en-US" sz="4800" dirty="0"/>
+          </a:p>
+        </p:txBody>
+      </p:sp>
+      <p:sp>
+        <p:nvSpPr>
+          <p:cNvPr id="16" name="Text 14"/>
+          <p:cNvSpPr txBox="1"/>
+          <p:nvPr/>
+        </p:nvSpPr>
+        <p:spPr>
+          <a:xfrm>
+            <a:off x="8412480" y="2788920"/>
+            <a:ext cx="2971800" cy="274320"/>
+          </a:xfrm>
+          <a:prstGeom prst="rect">
+            <a:avLst/>
+          </a:prstGeom>
+          <a:noFill/>
+          <a:ln/>
+        </p:spPr>
+        <p:txBody>
+          <a:bodyPr wrap="square" lIns="0" tIns="0" rIns="0" bIns="0" rtlCol="0" anchor="ctr"/>
+          <a:lstStyle/>
+          <a:p>
+            <a:pPr indent="0" marL="0">
+              <a:buNone/>
+            </a:pPr>
+            <a:r>
+              <a:rPr lang="en-US" sz="1100" b="1" spc="300" kern="0" dirty="0">
+                <a:solidFill>
+                  <a:srgbClr val="E0561F"/>
+                </a:solidFill>
+                <a:latin typeface="Calibri" pitchFamily="34" charset="0"/>
+                <a:ea typeface="Calibri" pitchFamily="34" charset="-122"/>
+                <a:cs typeface="Calibri" pitchFamily="34" charset="-120"/>
+              </a:rPr>
+              <a:t>THE MANAGER</a:t>
+            </a:r>
+            <a:endParaRPr lang="en-US" sz="1100" dirty="0"/>
+          </a:p>
+        </p:txBody>
+      </p:sp>
+      <p:sp>
+        <p:nvSpPr>
+          <p:cNvPr id="17" name="Text 15"/>
+          <p:cNvSpPr txBox="1"/>
+          <p:nvPr/>
+        </p:nvSpPr>
+        <p:spPr>
+          <a:xfrm>
+            <a:off x="8412480" y="3081528"/>
+            <a:ext cx="2971800" cy="411480"/>
+          </a:xfrm>
+          <a:prstGeom prst="rect">
+            <a:avLst/>
+          </a:prstGeom>
+          <a:noFill/>
+          <a:ln/>
+        </p:spPr>
+        <p:txBody>
+          <a:bodyPr wrap="square" lIns="0" tIns="0" rIns="0" bIns="0" rtlCol="0" anchor="ctr"/>
+          <a:lstStyle/>
+          <a:p>
+            <a:pPr indent="0" marL="0">
+              <a:buNone/>
+            </a:pPr>
+            <a:r>
+              <a:rPr lang="en-US" sz="1700" dirty="0">
+                <a:solidFill>
+                  <a:srgbClr val="1A1D21"/>
+                </a:solidFill>
+                <a:latin typeface="Cambria" pitchFamily="34" charset="0"/>
+                <a:ea typeface="Cambria" pitchFamily="34" charset="-122"/>
+                <a:cs typeface="Cambria" pitchFamily="34" charset="-120"/>
+              </a:rPr>
               <a:t>Managerial understanding</a:t>
             </a:r>
-            <a:endParaRPr lang="en-US" sz="1900" dirty="0"/>
-          </a:p>
-        </p:txBody>
-      </p:sp>
-      <p:sp>
-        <p:nvSpPr>
-          <p:cNvPr id="15" name="Text 10"/>
-          <p:cNvSpPr txBox="1"/>
-          <p:nvPr/>
-        </p:nvSpPr>
-        <p:spPr>
-          <a:xfrm>
-            <a:off x="8138160" y="4023360"/>
-            <a:ext cx="3520440" cy="2286000"/>
+            <a:endParaRPr lang="en-US" sz="1700" dirty="0"/>
+          </a:p>
+        </p:txBody>
+      </p:sp>
+      <p:sp>
+        <p:nvSpPr>
+          <p:cNvPr id="18" name="Text 16"/>
+          <p:cNvSpPr txBox="1"/>
+          <p:nvPr/>
+        </p:nvSpPr>
+        <p:spPr>
+          <a:xfrm>
+            <a:off x="8412480" y="3703320"/>
+            <a:ext cx="2971800" cy="2103120"/>
           </a:xfrm>
           <a:prstGeom prst="rect">
             <a:avLst/>
@@ -29746,13 +30302,13 @@
           <a:p>
             <a:pPr marL="342900" indent="-342900">
               <a:spcAft>
-                <a:spcPts val="600"/>
+                <a:spcPts val="1000"/>
               </a:spcAft>
               <a:buSzPct val="100000"/>
               <a:buChar char="•"/>
             </a:pPr>
             <a:r>
-              <a:rPr lang="en-US" sz="1300" dirty="0">
+              <a:rPr lang="en-US" sz="1400" dirty="0">
                 <a:solidFill>
                   <a:srgbClr val="3E4750"/>
                 </a:solidFill>
@@ -29762,18 +30318,18 @@
               </a:rPr>
               <a:t>Requirement gathering from users</a:t>
             </a:r>
-            <a:endParaRPr lang="en-US" sz="1300" dirty="0"/>
+            <a:endParaRPr lang="en-US" sz="1400" dirty="0"/>
           </a:p>
           <a:p>
             <a:pPr marL="342900" indent="-342900">
               <a:spcAft>
-                <a:spcPts val="600"/>
+                <a:spcPts val="1000"/>
               </a:spcAft>
               <a:buSzPct val="100000"/>
               <a:buChar char="•"/>
             </a:pPr>
             <a:r>
-              <a:rPr lang="en-US" sz="1300" dirty="0">
+              <a:rPr lang="en-US" sz="1400" dirty="0">
                 <a:solidFill>
                   <a:srgbClr val="3E4750"/>
                 </a:solidFill>
@@ -29783,18 +30339,18 @@
               </a:rPr>
               <a:t>A system is only useful if people adopt it</a:t>
             </a:r>
-            <a:endParaRPr lang="en-US" sz="1300" dirty="0"/>
+            <a:endParaRPr lang="en-US" sz="1400" dirty="0"/>
           </a:p>
           <a:p>
             <a:pPr marL="342900" indent="-342900">
               <a:spcAft>
-                <a:spcPts val="600"/>
+                <a:spcPts val="1000"/>
               </a:spcAft>
               <a:buSzPct val="100000"/>
               <a:buChar char="•"/>
             </a:pPr>
             <a:r>
-              <a:rPr lang="en-US" sz="1300" dirty="0">
+              <a:rPr lang="en-US" sz="1400" dirty="0">
                 <a:solidFill>
                   <a:srgbClr val="3E4750"/>
                 </a:solidFill>
@@ -29804,18 +30360,18 @@
               </a:rPr>
               <a:t>Scoping under time and tool constraints</a:t>
             </a:r>
-            <a:endParaRPr lang="en-US" sz="1300" dirty="0"/>
+            <a:endParaRPr lang="en-US" sz="1400" dirty="0"/>
           </a:p>
           <a:p>
             <a:pPr marL="342900" indent="-342900">
               <a:spcAft>
-                <a:spcPts val="600"/>
+                <a:spcPts val="1000"/>
               </a:spcAft>
               <a:buSzPct val="100000"/>
               <a:buChar char="•"/>
             </a:pPr>
             <a:r>
-              <a:rPr lang="en-US" sz="1300" dirty="0">
+              <a:rPr lang="en-US" sz="1400" dirty="0">
                 <a:solidFill>
                   <a:srgbClr val="3E4750"/>
                 </a:solidFill>
@@ -29825,13 +30381,13 @@
               </a:rPr>
               <a:t>Being honest about what it can't do</a:t>
             </a:r>
-            <a:endParaRPr lang="en-US" sz="1300" dirty="0"/>
-          </a:p>
-        </p:txBody>
-      </p:sp>
-      <p:sp>
-        <p:nvSpPr>
-          <p:cNvPr id="16" name="Text 11"/>
+            <a:endParaRPr lang="en-US" sz="1400" dirty="0"/>
+          </a:p>
+        </p:txBody>
+      </p:sp>
+      <p:sp>
+        <p:nvSpPr>
+          <p:cNvPr id="19" name="Text 17"/>
           <p:cNvSpPr txBox="1"/>
           <p:nvPr/>
         </p:nvSpPr>
@@ -31792,54 +32348,9 @@
           <a:chExt cx="0" cy="0"/>
         </a:xfrm>
       </p:grpSpPr>
-      <p:pic>
-        <p:nvPicPr>
-          <p:cNvPr id="2" name="Image 0" descr="/home/user/master-executive-system/sip-presentation/source/photos/1.jpg">    </p:cNvPr>
-          <p:cNvPicPr>
-            <a:picLocks noChangeAspect="1"/>
-          </p:cNvPicPr>
-          <p:nvPr/>
-        </p:nvPicPr>
-        <p:blipFill>
-          <a:blip r:embed="rId1"/>
-          <a:srcRect l="0" r="0" t="0" b="0"/>
-          <a:stretch/>
-        </p:blipFill>
-        <p:spPr>
-          <a:xfrm>
-            <a:off x="0" y="0"/>
-            <a:ext cx="12191695" cy="6858000"/>
-          </a:xfrm>
-          <a:prstGeom prst="rect">
-            <a:avLst/>
-          </a:prstGeom>
-        </p:spPr>
-      </p:pic>
-      <p:sp>
-        <p:nvSpPr>
-          <p:cNvPr id="3" name="Shape 0"/>
-          <p:cNvSpPr/>
-          <p:nvPr/>
-        </p:nvSpPr>
-        <p:spPr>
-          <a:xfrm>
-            <a:off x="0" y="0"/>
-            <a:ext cx="12191695" cy="6858000"/>
-          </a:xfrm>
-          <a:prstGeom prst="rect">
-            <a:avLst/>
-          </a:prstGeom>
-          <a:solidFill>
-            <a:srgbClr val="000000">
-              <a:alpha val="75000"/>
-            </a:srgbClr>
-          </a:solidFill>
-          <a:ln/>
-        </p:spPr>
-      </p:sp>
-      <p:sp>
-        <p:nvSpPr>
-          <p:cNvPr id="4" name="Text 1"/>
+      <p:sp>
+        <p:nvSpPr>
+          <p:cNvPr id="2" name="Text 0"/>
           <p:cNvSpPr txBox="1"/>
           <p:nvPr/>
         </p:nvSpPr>
@@ -31878,7 +32389,7 @@
       </p:sp>
       <p:sp>
         <p:nvSpPr>
-          <p:cNvPr id="5" name="Text 2"/>
+          <p:cNvPr id="3" name="Text 1"/>
           <p:cNvSpPr txBox="1"/>
           <p:nvPr/>
         </p:nvSpPr>
@@ -31917,7 +32428,7 @@
       </p:sp>
       <p:sp>
         <p:nvSpPr>
-          <p:cNvPr id="6" name="Text 3"/>
+          <p:cNvPr id="4" name="Text 2"/>
           <p:cNvSpPr txBox="1"/>
           <p:nvPr/>
         </p:nvSpPr>
@@ -31956,7 +32467,7 @@
       </p:sp>
       <p:sp>
         <p:nvSpPr>
-          <p:cNvPr id="7" name="Text 4"/>
+          <p:cNvPr id="5" name="Text 3"/>
           <p:cNvSpPr txBox="1"/>
           <p:nvPr/>
         </p:nvSpPr>
@@ -31995,7 +32506,7 @@
       </p:sp>
       <p:sp>
         <p:nvSpPr>
-          <p:cNvPr id="8" name="Text 5"/>
+          <p:cNvPr id="6" name="Text 4"/>
           <p:cNvSpPr txBox="1"/>
           <p:nvPr/>
         </p:nvSpPr>
@@ -37519,7 +38030,7 @@
         </p:nvSpPr>
         <p:spPr>
           <a:xfrm>
-            <a:off x="548640" y="2971800"/>
+            <a:off x="548640" y="2743200"/>
             <a:ext cx="3931920" cy="457200"/>
           </a:xfrm>
           <a:prstGeom prst="rect">
@@ -37558,7 +38069,7 @@
         </p:nvSpPr>
         <p:spPr>
           <a:xfrm>
-            <a:off x="548640" y="3429000"/>
+            <a:off x="548640" y="3200400"/>
             <a:ext cx="3840480" cy="777240"/>
           </a:xfrm>
           <a:prstGeom prst="rect">
@@ -37597,7 +38108,7 @@
         </p:nvSpPr>
         <p:spPr>
           <a:xfrm>
-            <a:off x="548640" y="4343400"/>
+            <a:off x="548640" y="3886200"/>
             <a:ext cx="3931920" cy="457200"/>
           </a:xfrm>
           <a:prstGeom prst="rect">
@@ -37636,7 +38147,7 @@
         </p:nvSpPr>
         <p:spPr>
           <a:xfrm>
-            <a:off x="548640" y="4800600"/>
+            <a:off x="548640" y="4343400"/>
             <a:ext cx="3840480" cy="777240"/>
           </a:xfrm>
           <a:prstGeom prst="rect">
@@ -37715,7 +38226,7 @@
         <p:spPr>
           <a:xfrm>
             <a:off x="4937760" y="2011680"/>
-            <a:ext cx="6702552" cy="1005840"/>
+            <a:ext cx="6702552" cy="896112"/>
           </a:xfrm>
           <a:prstGeom prst="rect">
             <a:avLst/>
@@ -37739,8 +38250,8 @@
         </p:nvSpPr>
         <p:spPr>
           <a:xfrm>
-            <a:off x="5120640" y="2121408"/>
-            <a:ext cx="1645920" cy="786384"/>
+            <a:off x="5120640" y="2084832"/>
+            <a:ext cx="1645920" cy="749808"/>
           </a:xfrm>
           <a:prstGeom prst="rect">
             <a:avLst/>
@@ -37795,7 +38306,7 @@
         </p:nvSpPr>
         <p:spPr>
           <a:xfrm>
-            <a:off x="6812280" y="2340864"/>
+            <a:off x="6812280" y="2286000"/>
             <a:ext cx="804672" cy="347472"/>
           </a:xfrm>
           <a:prstGeom prst="roundRect">
@@ -37817,7 +38328,7 @@
         </p:nvSpPr>
         <p:spPr>
           <a:xfrm>
-            <a:off x="6812280" y="2340864"/>
+            <a:off x="6812280" y="2286000"/>
             <a:ext cx="804672" cy="347472"/>
           </a:xfrm>
           <a:prstGeom prst="rect">
@@ -37856,7 +38367,7 @@
         </p:nvSpPr>
         <p:spPr>
           <a:xfrm>
-            <a:off x="7616952" y="2340864"/>
+            <a:off x="7616952" y="2286000"/>
             <a:ext cx="146304" cy="347472"/>
           </a:xfrm>
           <a:prstGeom prst="rect">
@@ -37895,7 +38406,7 @@
         </p:nvSpPr>
         <p:spPr>
           <a:xfrm>
-            <a:off x="7763256" y="2340864"/>
+            <a:off x="7763256" y="2286000"/>
             <a:ext cx="680314" cy="347472"/>
           </a:xfrm>
           <a:prstGeom prst="roundRect">
@@ -37917,7 +38428,7 @@
         </p:nvSpPr>
         <p:spPr>
           <a:xfrm>
-            <a:off x="7763256" y="2340864"/>
+            <a:off x="7763256" y="2286000"/>
             <a:ext cx="680314" cy="347472"/>
           </a:xfrm>
           <a:prstGeom prst="rect">
@@ -37956,7 +38467,7 @@
         </p:nvSpPr>
         <p:spPr>
           <a:xfrm>
-            <a:off x="8443570" y="2340864"/>
+            <a:off x="8443570" y="2286000"/>
             <a:ext cx="146304" cy="347472"/>
           </a:xfrm>
           <a:prstGeom prst="rect">
@@ -37995,7 +38506,7 @@
         </p:nvSpPr>
         <p:spPr>
           <a:xfrm>
-            <a:off x="8589874" y="2340864"/>
+            <a:off x="8589874" y="2286000"/>
             <a:ext cx="1053389" cy="347472"/>
           </a:xfrm>
           <a:prstGeom prst="roundRect">
@@ -38017,7 +38528,7 @@
         </p:nvSpPr>
         <p:spPr>
           <a:xfrm>
-            <a:off x="8589874" y="2340864"/>
+            <a:off x="8589874" y="2286000"/>
             <a:ext cx="1053389" cy="347472"/>
           </a:xfrm>
           <a:prstGeom prst="rect">
@@ -38056,7 +38567,7 @@
         </p:nvSpPr>
         <p:spPr>
           <a:xfrm>
-            <a:off x="9643262" y="2340864"/>
+            <a:off x="9643262" y="2286000"/>
             <a:ext cx="146304" cy="347472"/>
           </a:xfrm>
           <a:prstGeom prst="rect">
@@ -38095,7 +38606,7 @@
         </p:nvSpPr>
         <p:spPr>
           <a:xfrm>
-            <a:off x="9789566" y="2340864"/>
+            <a:off x="9789566" y="2286000"/>
             <a:ext cx="929030" cy="347472"/>
           </a:xfrm>
           <a:prstGeom prst="roundRect">
@@ -38117,7 +38628,7 @@
         </p:nvSpPr>
         <p:spPr>
           <a:xfrm>
-            <a:off x="9789566" y="2340864"/>
+            <a:off x="9789566" y="2286000"/>
             <a:ext cx="929030" cy="347472"/>
           </a:xfrm>
           <a:prstGeom prst="rect">
@@ -38156,8 +38667,8 @@
         </p:nvSpPr>
         <p:spPr>
           <a:xfrm>
-            <a:off x="4937760" y="3200400"/>
-            <a:ext cx="6702552" cy="1005840"/>
+            <a:off x="4937760" y="3035808"/>
+            <a:ext cx="6702552" cy="896112"/>
           </a:xfrm>
           <a:prstGeom prst="rect">
             <a:avLst/>
@@ -38181,8 +38692,8 @@
         </p:nvSpPr>
         <p:spPr>
           <a:xfrm>
-            <a:off x="5120640" y="3310128"/>
-            <a:ext cx="1645920" cy="786384"/>
+            <a:off x="5120640" y="3108960"/>
+            <a:ext cx="1645920" cy="749808"/>
           </a:xfrm>
           <a:prstGeom prst="rect">
             <a:avLst/>
@@ -38237,7 +38748,7 @@
         </p:nvSpPr>
         <p:spPr>
           <a:xfrm>
-            <a:off x="6812280" y="3529584"/>
+            <a:off x="6812280" y="3310128"/>
             <a:ext cx="1115568" cy="347472"/>
           </a:xfrm>
           <a:prstGeom prst="roundRect">
@@ -38259,7 +38770,7 @@
         </p:nvSpPr>
         <p:spPr>
           <a:xfrm>
-            <a:off x="6812280" y="3529584"/>
+            <a:off x="6812280" y="3310128"/>
             <a:ext cx="1115568" cy="347472"/>
           </a:xfrm>
           <a:prstGeom prst="rect">
@@ -38298,7 +38809,7 @@
         </p:nvSpPr>
         <p:spPr>
           <a:xfrm>
-            <a:off x="7927848" y="3529584"/>
+            <a:off x="7927848" y="3310128"/>
             <a:ext cx="146304" cy="347472"/>
           </a:xfrm>
           <a:prstGeom prst="rect">
@@ -38337,7 +38848,7 @@
         </p:nvSpPr>
         <p:spPr>
           <a:xfrm>
-            <a:off x="8074152" y="3529584"/>
+            <a:off x="8074152" y="3310128"/>
             <a:ext cx="618134" cy="347472"/>
           </a:xfrm>
           <a:prstGeom prst="roundRect">
@@ -38359,7 +38870,7 @@
         </p:nvSpPr>
         <p:spPr>
           <a:xfrm>
-            <a:off x="8074152" y="3529584"/>
+            <a:off x="8074152" y="3310128"/>
             <a:ext cx="618134" cy="347472"/>
           </a:xfrm>
           <a:prstGeom prst="rect">
@@ -38398,7 +38909,7 @@
         </p:nvSpPr>
         <p:spPr>
           <a:xfrm>
-            <a:off x="8692286" y="3529584"/>
+            <a:off x="8692286" y="3310128"/>
             <a:ext cx="146304" cy="347472"/>
           </a:xfrm>
           <a:prstGeom prst="rect">
@@ -38437,7 +38948,7 @@
         </p:nvSpPr>
         <p:spPr>
           <a:xfrm>
-            <a:off x="8838590" y="3529584"/>
+            <a:off x="8838590" y="3310128"/>
             <a:ext cx="680314" cy="347472"/>
           </a:xfrm>
           <a:prstGeom prst="roundRect">
@@ -38459,7 +38970,7 @@
         </p:nvSpPr>
         <p:spPr>
           <a:xfrm>
-            <a:off x="8838590" y="3529584"/>
+            <a:off x="8838590" y="3310128"/>
             <a:ext cx="680314" cy="347472"/>
           </a:xfrm>
           <a:prstGeom prst="rect">
@@ -38498,7 +39009,7 @@
         </p:nvSpPr>
         <p:spPr>
           <a:xfrm>
-            <a:off x="9518904" y="3529584"/>
+            <a:off x="9518904" y="3310128"/>
             <a:ext cx="146304" cy="347472"/>
           </a:xfrm>
           <a:prstGeom prst="rect">
@@ -38537,7 +39048,7 @@
         </p:nvSpPr>
         <p:spPr>
           <a:xfrm>
-            <a:off x="9665208" y="3529584"/>
+            <a:off x="9665208" y="3310128"/>
             <a:ext cx="929030" cy="347472"/>
           </a:xfrm>
           <a:prstGeom prst="roundRect">
@@ -38559,7 +39070,7 @@
         </p:nvSpPr>
         <p:spPr>
           <a:xfrm>
-            <a:off x="9665208" y="3529584"/>
+            <a:off x="9665208" y="3310128"/>
             <a:ext cx="929030" cy="347472"/>
           </a:xfrm>
           <a:prstGeom prst="rect">
@@ -38598,7 +39109,7 @@
         </p:nvSpPr>
         <p:spPr>
           <a:xfrm>
-            <a:off x="10594238" y="3529584"/>
+            <a:off x="10594238" y="3310128"/>
             <a:ext cx="146304" cy="347472"/>
           </a:xfrm>
           <a:prstGeom prst="rect">
@@ -38637,7 +39148,7 @@
         </p:nvSpPr>
         <p:spPr>
           <a:xfrm>
-            <a:off x="10740542" y="3529584"/>
+            <a:off x="10740542" y="3310128"/>
             <a:ext cx="618134" cy="347472"/>
           </a:xfrm>
           <a:prstGeom prst="roundRect">
@@ -38659,7 +39170,7 @@
         </p:nvSpPr>
         <p:spPr>
           <a:xfrm>
-            <a:off x="10740542" y="3529584"/>
+            <a:off x="10740542" y="3310128"/>
             <a:ext cx="618134" cy="347472"/>
           </a:xfrm>
           <a:prstGeom prst="rect">
@@ -38698,8 +39209,8 @@
         </p:nvSpPr>
         <p:spPr>
           <a:xfrm>
-            <a:off x="4937760" y="4389120"/>
-            <a:ext cx="6702552" cy="1005840"/>
+            <a:off x="4937760" y="4059936"/>
+            <a:ext cx="6702552" cy="896112"/>
           </a:xfrm>
           <a:prstGeom prst="rect">
             <a:avLst/>
@@ -38723,8 +39234,8 @@
         </p:nvSpPr>
         <p:spPr>
           <a:xfrm>
-            <a:off x="5120640" y="4498848"/>
-            <a:ext cx="1645920" cy="786384"/>
+            <a:off x="5120640" y="4133088"/>
+            <a:ext cx="1645920" cy="749808"/>
           </a:xfrm>
           <a:prstGeom prst="rect">
             <a:avLst/>
@@ -38779,7 +39290,7 @@
         </p:nvSpPr>
         <p:spPr>
           <a:xfrm>
-            <a:off x="6812280" y="4718304"/>
+            <a:off x="6812280" y="4334256"/>
             <a:ext cx="866851" cy="347472"/>
           </a:xfrm>
           <a:prstGeom prst="roundRect">
@@ -38801,7 +39312,7 @@
         </p:nvSpPr>
         <p:spPr>
           <a:xfrm>
-            <a:off x="6812280" y="4718304"/>
+            <a:off x="6812280" y="4334256"/>
             <a:ext cx="866851" cy="347472"/>
           </a:xfrm>
           <a:prstGeom prst="rect">
@@ -38840,8 +39351,8 @@
         </p:nvSpPr>
         <p:spPr>
           <a:xfrm>
-            <a:off x="4937760" y="5669280"/>
-            <a:ext cx="6702552" cy="685800"/>
+            <a:off x="4937760" y="5029200"/>
+            <a:ext cx="6702552" cy="594360"/>
           </a:xfrm>
           <a:prstGeom prst="rect">
             <a:avLst/>
@@ -38873,7 +39384,225 @@
       </p:sp>
       <p:sp>
         <p:nvSpPr>
-          <p:cNvPr id="45" name="Text 43"/>
+          <p:cNvPr id="45" name="Shape 43"/>
+          <p:cNvSpPr/>
+          <p:nvPr/>
+        </p:nvSpPr>
+        <p:spPr>
+          <a:xfrm>
+            <a:off x="548640" y="5715000"/>
+            <a:ext cx="11091672" cy="0"/>
+          </a:xfrm>
+          <a:prstGeom prst="line">
+            <a:avLst/>
+          </a:prstGeom>
+          <a:noFill/>
+          <a:ln w="9525">
+            <a:solidFill>
+              <a:srgbClr val="D6D8D6"/>
+            </a:solidFill>
+            <a:prstDash val="solid"/>
+          </a:ln>
+        </p:spPr>
+      </p:sp>
+      <p:sp>
+        <p:nvSpPr>
+          <p:cNvPr id="46" name="Text 44"/>
+          <p:cNvSpPr txBox="1"/>
+          <p:nvPr/>
+        </p:nvSpPr>
+        <p:spPr>
+          <a:xfrm>
+            <a:off x="548640" y="5833872"/>
+            <a:ext cx="2926080" cy="457200"/>
+          </a:xfrm>
+          <a:prstGeom prst="rect">
+            <a:avLst/>
+          </a:prstGeom>
+          <a:noFill/>
+          <a:ln/>
+        </p:spPr>
+        <p:txBody>
+          <a:bodyPr wrap="square" lIns="0" tIns="0" rIns="0" bIns="0" rtlCol="0" anchor="ctr"/>
+          <a:lstStyle/>
+          <a:p>
+            <a:pPr indent="0" marL="0">
+              <a:buNone/>
+            </a:pPr>
+            <a:r>
+              <a:rPr lang="en-US" sz="900" b="1" spc="200" kern="0" dirty="0">
+                <a:solidFill>
+                  <a:srgbClr val="6B7278"/>
+                </a:solidFill>
+                <a:latin typeface="Calibri" pitchFamily="34" charset="0"/>
+                <a:ea typeface="Calibri" pitchFamily="34" charset="-122"/>
+                <a:cs typeface="Calibri" pitchFamily="34" charset="-120"/>
+              </a:rPr>
+              <a:t>CONTRACT-MANUFACTURING CLIENTS, PUBLICLY REPORTED</a:t>
+            </a:r>
+            <a:endParaRPr lang="en-US" sz="900" dirty="0"/>
+          </a:p>
+        </p:txBody>
+      </p:sp>
+      <p:sp>
+        <p:nvSpPr>
+          <p:cNvPr id="47" name="Text 45"/>
+          <p:cNvSpPr txBox="1"/>
+          <p:nvPr/>
+        </p:nvSpPr>
+        <p:spPr>
+          <a:xfrm>
+            <a:off x="3703320" y="5833872"/>
+            <a:ext cx="2011680" cy="457200"/>
+          </a:xfrm>
+          <a:prstGeom prst="rect">
+            <a:avLst/>
+          </a:prstGeom>
+          <a:noFill/>
+          <a:ln/>
+        </p:spPr>
+        <p:txBody>
+          <a:bodyPr wrap="square" lIns="0" tIns="0" rIns="0" bIns="0" rtlCol="0" anchor="ctr"/>
+          <a:lstStyle/>
+          <a:p>
+            <a:pPr indent="0" marL="0">
+              <a:buNone/>
+            </a:pPr>
+            <a:r>
+              <a:rPr lang="en-US" sz="1400" dirty="0">
+                <a:solidFill>
+                  <a:srgbClr val="1A1D21"/>
+                </a:solidFill>
+                <a:latin typeface="Cambria" pitchFamily="34" charset="0"/>
+                <a:ea typeface="Cambria" pitchFamily="34" charset="-122"/>
+                <a:cs typeface="Cambria" pitchFamily="34" charset="-120"/>
+              </a:rPr>
+              <a:t>Dabur India</a:t>
+            </a:r>
+            <a:endParaRPr lang="en-US" sz="1400" dirty="0"/>
+          </a:p>
+        </p:txBody>
+      </p:sp>
+      <p:sp>
+        <p:nvSpPr>
+          <p:cNvPr id="48" name="Text 46"/>
+          <p:cNvSpPr txBox="1"/>
+          <p:nvPr/>
+        </p:nvSpPr>
+        <p:spPr>
+          <a:xfrm>
+            <a:off x="5852160" y="5833872"/>
+            <a:ext cx="2011680" cy="457200"/>
+          </a:xfrm>
+          <a:prstGeom prst="rect">
+            <a:avLst/>
+          </a:prstGeom>
+          <a:noFill/>
+          <a:ln/>
+        </p:spPr>
+        <p:txBody>
+          <a:bodyPr wrap="square" lIns="0" tIns="0" rIns="0" bIns="0" rtlCol="0" anchor="ctr"/>
+          <a:lstStyle/>
+          <a:p>
+            <a:pPr indent="0" marL="0">
+              <a:buNone/>
+            </a:pPr>
+            <a:r>
+              <a:rPr lang="en-US" sz="1400" dirty="0">
+                <a:solidFill>
+                  <a:srgbClr val="1A1D21"/>
+                </a:solidFill>
+                <a:latin typeface="Cambria" pitchFamily="34" charset="0"/>
+                <a:ea typeface="Cambria" pitchFamily="34" charset="-122"/>
+                <a:cs typeface="Cambria" pitchFamily="34" charset="-120"/>
+              </a:rPr>
+              <a:t>Patanjali Ayurved</a:t>
+            </a:r>
+            <a:endParaRPr lang="en-US" sz="1400" dirty="0"/>
+          </a:p>
+        </p:txBody>
+      </p:sp>
+      <p:sp>
+        <p:nvSpPr>
+          <p:cNvPr id="49" name="Text 47"/>
+          <p:cNvSpPr txBox="1"/>
+          <p:nvPr/>
+        </p:nvSpPr>
+        <p:spPr>
+          <a:xfrm>
+            <a:off x="8001000" y="5833872"/>
+            <a:ext cx="2011680" cy="457200"/>
+          </a:xfrm>
+          <a:prstGeom prst="rect">
+            <a:avLst/>
+          </a:prstGeom>
+          <a:noFill/>
+          <a:ln/>
+        </p:spPr>
+        <p:txBody>
+          <a:bodyPr wrap="square" lIns="0" tIns="0" rIns="0" bIns="0" rtlCol="0" anchor="ctr"/>
+          <a:lstStyle/>
+          <a:p>
+            <a:pPr indent="0" marL="0">
+              <a:buNone/>
+            </a:pPr>
+            <a:r>
+              <a:rPr lang="en-US" sz="1400" dirty="0">
+                <a:solidFill>
+                  <a:srgbClr val="1A1D21"/>
+                </a:solidFill>
+                <a:latin typeface="Cambria" pitchFamily="34" charset="0"/>
+                <a:ea typeface="Cambria" pitchFamily="34" charset="-122"/>
+                <a:cs typeface="Cambria" pitchFamily="34" charset="-120"/>
+              </a:rPr>
+              <a:t>Amway India</a:t>
+            </a:r>
+            <a:endParaRPr lang="en-US" sz="1400" dirty="0"/>
+          </a:p>
+        </p:txBody>
+      </p:sp>
+      <p:sp>
+        <p:nvSpPr>
+          <p:cNvPr id="50" name="Text 48"/>
+          <p:cNvSpPr txBox="1"/>
+          <p:nvPr/>
+        </p:nvSpPr>
+        <p:spPr>
+          <a:xfrm>
+            <a:off x="10149840" y="6355080"/>
+            <a:ext cx="1097280" cy="201168"/>
+          </a:xfrm>
+          <a:prstGeom prst="rect">
+            <a:avLst/>
+          </a:prstGeom>
+          <a:noFill/>
+          <a:ln/>
+        </p:spPr>
+        <p:txBody>
+          <a:bodyPr wrap="square" lIns="0" tIns="0" rIns="0" bIns="0" rtlCol="0" anchor="ctr"/>
+          <a:lstStyle/>
+          <a:p>
+            <a:pPr indent="0" marL="0">
+              <a:buNone/>
+            </a:pPr>
+            <a:r>
+              <a:rPr lang="en-US" sz="750" i="1" dirty="0">
+                <a:solidFill>
+                  <a:srgbClr val="6B7278"/>
+                </a:solidFill>
+                <a:latin typeface="Calibri" pitchFamily="34" charset="0"/>
+                <a:ea typeface="Calibri" pitchFamily="34" charset="-122"/>
+                <a:cs typeface="Calibri" pitchFamily="34" charset="-120"/>
+              </a:rPr>
+              <a:t>Sources in speaker notes</a:t>
+            </a:r>
+            <a:endParaRPr lang="en-US" sz="750" dirty="0"/>
+          </a:p>
+        </p:txBody>
+      </p:sp>
+      <p:sp>
+        <p:nvSpPr>
+          <p:cNvPr id="51" name="Text 49"/>
           <p:cNvSpPr txBox="1"/>
           <p:nvPr/>
         </p:nvSpPr>
@@ -38944,7 +39673,7 @@
       </p:grpSpPr>
       <p:pic>
         <p:nvPicPr>
-          <p:cNvPr id="2" name="Image 0" descr="/home/user/master-executive-system/sip-presentation/source/photos/3.jpg">    </p:cNvPr>
+          <p:cNvPr id="2" name="Image 0" descr="/home/user/master-executive-system/sip-presentation/source/photos/2.jpg">    </p:cNvPr>
           <p:cNvPicPr>
             <a:picLocks noChangeAspect="1"/>
           </p:cNvPicPr>
@@ -38958,62 +39687,16 @@
         <p:spPr>
           <a:xfrm>
             <a:off x="0" y="0"/>
-            <a:ext cx="7498080" cy="6858000"/>
+            <a:ext cx="12191695" cy="6858000"/>
           </a:xfrm>
           <a:prstGeom prst="rect">
             <a:avLst/>
           </a:prstGeom>
         </p:spPr>
       </p:pic>
-      <p:pic>
-        <p:nvPicPr>
-          <p:cNvPr id="3" name="Image 1" descr="/home/user/master-executive-system/sip-presentation/source/photos/4.jpg">    </p:cNvPr>
-          <p:cNvPicPr>
-            <a:picLocks noChangeAspect="1"/>
-          </p:cNvPicPr>
-          <p:nvPr/>
-        </p:nvPicPr>
-        <p:blipFill>
-          <a:blip r:embed="rId2"/>
-          <a:srcRect l="0" r="0" t="0" b="0"/>
-          <a:stretch/>
-        </p:blipFill>
-        <p:spPr>
-          <a:xfrm>
-            <a:off x="7571232" y="0"/>
-            <a:ext cx="4620463" cy="3383280"/>
-          </a:xfrm>
-          <a:prstGeom prst="rect">
-            <a:avLst/>
-          </a:prstGeom>
-        </p:spPr>
-      </p:pic>
-      <p:pic>
-        <p:nvPicPr>
-          <p:cNvPr id="4" name="Image 2" descr="/home/user/master-executive-system/sip-presentation/source/photos/2.jpg">    </p:cNvPr>
-          <p:cNvPicPr>
-            <a:picLocks noChangeAspect="1"/>
-          </p:cNvPicPr>
-          <p:nvPr/>
-        </p:nvPicPr>
-        <p:blipFill>
-          <a:blip r:embed="rId3"/>
-          <a:srcRect l="0" r="0" t="0" b="0"/>
-          <a:stretch/>
-        </p:blipFill>
-        <p:spPr>
-          <a:xfrm>
-            <a:off x="7571232" y="3456432"/>
-            <a:ext cx="4620463" cy="3401568"/>
-          </a:xfrm>
-          <a:prstGeom prst="rect">
-            <a:avLst/>
-          </a:prstGeom>
-        </p:spPr>
-      </p:pic>
-      <p:sp>
-        <p:nvSpPr>
-          <p:cNvPr id="5" name="Shape 0"/>
+      <p:sp>
+        <p:nvSpPr>
+          <p:cNvPr id="3" name="Shape 0"/>
           <p:cNvSpPr/>
           <p:nvPr/>
         </p:nvSpPr>
@@ -39035,7 +39718,7 @@
       </p:sp>
       <p:sp>
         <p:nvSpPr>
-          <p:cNvPr id="6" name="Text 1"/>
+          <p:cNvPr id="4" name="Text 1"/>
           <p:cNvSpPr txBox="1"/>
           <p:nvPr/>
         </p:nvSpPr>
@@ -39074,7 +39757,7 @@
       </p:sp>
       <p:sp>
         <p:nvSpPr>
-          <p:cNvPr id="7" name="Text 2"/>
+          <p:cNvPr id="5" name="Text 2"/>
           <p:cNvSpPr txBox="1"/>
           <p:nvPr/>
         </p:nvSpPr>
@@ -39113,48 +39796,26 @@
       </p:sp>
       <p:sp>
         <p:nvSpPr>
-          <p:cNvPr id="8" name="Shape 3"/>
-          <p:cNvSpPr/>
-          <p:nvPr/>
-        </p:nvSpPr>
-        <p:spPr>
-          <a:xfrm>
-            <a:off x="7571232" y="2999232"/>
-            <a:ext cx="4620463" cy="384048"/>
-          </a:xfrm>
-          <a:prstGeom prst="rect">
-            <a:avLst/>
-          </a:prstGeom>
-          <a:solidFill>
-            <a:srgbClr val="000000">
-              <a:alpha val="60000"/>
-            </a:srgbClr>
-          </a:solidFill>
-          <a:ln/>
-        </p:spPr>
-      </p:sp>
-      <p:sp>
-        <p:nvSpPr>
-          <p:cNvPr id="9" name="Text 4"/>
-          <p:cNvSpPr txBox="1"/>
-          <p:nvPr/>
-        </p:nvSpPr>
-        <p:spPr>
-          <a:xfrm>
-            <a:off x="7726680" y="3072384"/>
-            <a:ext cx="4206240" cy="228600"/>
-          </a:xfrm>
-          <a:prstGeom prst="rect">
-            <a:avLst/>
-          </a:prstGeom>
-          <a:noFill/>
-          <a:ln/>
-        </p:spPr>
-        <p:txBody>
-          <a:bodyPr wrap="square" lIns="0" tIns="0" rIns="0" bIns="0" rtlCol="0" anchor="ctr"/>
-          <a:lstStyle/>
-          <a:p>
-            <a:pPr indent="0" marL="0">
+          <p:cNvPr id="6" name="Text 3"/>
+          <p:cNvSpPr txBox="1"/>
+          <p:nvPr/>
+        </p:nvSpPr>
+        <p:spPr>
+          <a:xfrm>
+            <a:off x="7589520" y="6400800"/>
+            <a:ext cx="4023360" cy="228600"/>
+          </a:xfrm>
+          <a:prstGeom prst="rect">
+            <a:avLst/>
+          </a:prstGeom>
+          <a:noFill/>
+          <a:ln/>
+        </p:spPr>
+        <p:txBody>
+          <a:bodyPr wrap="square" lIns="0" tIns="0" rIns="0" bIns="0" rtlCol="0" anchor="ctr"/>
+          <a:lstStyle/>
+          <a:p>
+            <a:pPr algn="r" indent="0" marL="0">
               <a:buNone/>
             </a:pPr>
             <a:r>
@@ -39166,7 +39827,7 @@
                 <a:ea typeface="Calibri" pitchFamily="34" charset="-122"/>
                 <a:cs typeface="Calibri" pitchFamily="34" charset="-120"/>
               </a:rPr>
-              <a:t>Tube filling line, paste plant</a:t>
+              <a:t>Kala-Amb industrial belt from the plant roof</a:t>
             </a:r>
             <a:endParaRPr lang="en-US" sz="1000" dirty="0"/>
           </a:p>
@@ -39174,68 +39835,7 @@
       </p:sp>
       <p:sp>
         <p:nvSpPr>
-          <p:cNvPr id="10" name="Shape 5"/>
-          <p:cNvSpPr/>
-          <p:nvPr/>
-        </p:nvSpPr>
-        <p:spPr>
-          <a:xfrm>
-            <a:off x="7571232" y="6400800"/>
-            <a:ext cx="4620463" cy="457200"/>
-          </a:xfrm>
-          <a:prstGeom prst="rect">
-            <a:avLst/>
-          </a:prstGeom>
-          <a:solidFill>
-            <a:srgbClr val="000000">
-              <a:alpha val="60000"/>
-            </a:srgbClr>
-          </a:solidFill>
-          <a:ln/>
-        </p:spPr>
-      </p:sp>
-      <p:sp>
-        <p:nvSpPr>
-          <p:cNvPr id="11" name="Text 6"/>
-          <p:cNvSpPr txBox="1"/>
-          <p:nvPr/>
-        </p:nvSpPr>
-        <p:spPr>
-          <a:xfrm>
-            <a:off x="7726680" y="6528816"/>
-            <a:ext cx="4206240" cy="228600"/>
-          </a:xfrm>
-          <a:prstGeom prst="rect">
-            <a:avLst/>
-          </a:prstGeom>
-          <a:noFill/>
-          <a:ln/>
-        </p:spPr>
-        <p:txBody>
-          <a:bodyPr wrap="square" lIns="0" tIns="0" rIns="0" bIns="0" rtlCol="0" anchor="ctr"/>
-          <a:lstStyle/>
-          <a:p>
-            <a:pPr indent="0" marL="0">
-              <a:buNone/>
-            </a:pPr>
-            <a:r>
-              <a:rPr lang="en-US" sz="1000" dirty="0">
-                <a:solidFill>
-                  <a:srgbClr val="FFFFFF"/>
-                </a:solidFill>
-                <a:latin typeface="Calibri" pitchFamily="34" charset="0"/>
-                <a:ea typeface="Calibri" pitchFamily="34" charset="-122"/>
-                <a:cs typeface="Calibri" pitchFamily="34" charset="-120"/>
-              </a:rPr>
-              <a:t>Kala-Amb industrial belt from the plant roof</a:t>
-            </a:r>
-            <a:endParaRPr lang="en-US" sz="1000" dirty="0"/>
-          </a:p>
-        </p:txBody>
-      </p:sp>
-      <p:sp>
-        <p:nvSpPr>
-          <p:cNvPr id="12" name="Text 7"/>
+          <p:cNvPr id="7" name="Text 4"/>
           <p:cNvSpPr txBox="1"/>
           <p:nvPr/>
         </p:nvSpPr>

</xml_diff>